<commit_message>
Fix orphaned-part corruption risk from the earlier slide removal
The slide-13/37 removal in 50768ea only unlisted them from sldIdLst
without dropping the underlying relationships (rId15->slide13.xml,
rId39->slide37.xml stayed related to the presentation part). The
file was structurally valid as committed, but every subsequent
python-pptx save silently produced a duplicate zip entry for
ppt/slides/slide13.xml (caught mid-edit by zipfile's own warning
before it could be saved over the good copy). Properly dropped both
orphaned relationships via Part.drop_rel() this time and stress-
tested three consecutive saves with a zip-level duplicate check
after each — clean throughout. Also fixed a stale "slide 10's
scorecard" note reference (pre-existing, unrelated to today's
edits) to point at the actual Security Goals G1-G4 slide.
</commit_message>
<xml_diff>
--- a/thesis_defense/lifi_thesis_defense.pptx
+++ b/thesis_defense/lifi_thesis_defense.pptx
@@ -567,76 +567,6 @@
 </p:notes>
 </file>
 
-<file path=ppt/notesSlides/notesSlide13.xml><?xml version="1.0" encoding="utf-8"?>
-<p:notes xmlns:a="http://schemas.openxmlformats.org/drawingml/2006/main" xmlns:r="http://schemas.openxmlformats.org/officeDocument/2006/relationships" xmlns:p="http://schemas.openxmlformats.org/presentationml/2006/main">
-  <p:cSld>
-    <p:spTree>
-      <p:nvGrpSpPr>
-        <p:cNvPr id="1" name=""/>
-        <p:cNvGrpSpPr/>
-        <p:nvPr/>
-      </p:nvGrpSpPr>
-      <p:grpSpPr>
-        <a:xfrm>
-          <a:off x="0" y="0"/>
-          <a:ext cx="0" cy="0"/>
-          <a:chOff x="0" y="0"/>
-          <a:chExt cx="0" cy="0"/>
-        </a:xfrm>
-      </p:grpSpPr>
-      <p:sp>
-        <p:nvSpPr>
-          <p:cNvPr id="2" name="Slide Image Placeholder 1"/>
-          <p:cNvSpPr>
-            <a:spLocks noGrp="1" noRot="1" noChangeAspect="1"/>
-          </p:cNvSpPr>
-          <p:nvPr>
-            <p:ph type="sldImg" idx="2"/>
-          </p:nvPr>
-        </p:nvSpPr>
-        <p:spPr/>
-      </p:sp>
-      <p:sp>
-        <p:nvSpPr>
-          <p:cNvPr id="3" name="Notes Placeholder 2"/>
-          <p:cNvSpPr>
-            <a:spLocks noGrp="1"/>
-          </p:cNvSpPr>
-          <p:nvPr>
-            <p:ph type="body" sz="quarter" idx="3"/>
-          </p:nvPr>
-        </p:nvSpPr>
-        <p:spPr/>
-        <p:txBody>
-          <a:bodyPr/>
-          <a:lstStyle/>
-          <a:p>
-            <a:r>
-              <a:t>Two things happen with Auth in the loop that are easy to miss if you only think of provisioning as a one-time boot-up handshake. Phase one: a device entering a room broadcasts only its non-secret 8-byte key ID over light — never the session key itself. If the receiver doesn't already recognize that ID locally, it performs what the code literally calls a roaming lookup — get_session_key_by_ID over mutual TLS to the Auth server. Auth can return the session key for a valid, registered device, or reject the request outright for an unknown or revoked one. That rejection path is a second, distinct revocation mechanism from G4: G4 revokes because the physical light signal stopped; this revokes because Auth, administratively, said no — identity-layer revocation versus physical-layer revocation, and they're complementary, not redundant. Phase two: at any point after that, the receiver can issue a live HMAC challenge to the sender over the same optical or UART link — a fresh random challenge, HMAC-SHA256 under the session MAC key, AES-GCM-encrypted response, compared locally. That's a stronger, on-demand proof of live key possession, layered on top of the passive 'this frame decrypted successfully' freshness check the whole G1/G4 evaluation is built on. If asked why both mechanisms exist: the passive heartbeat check is what's continuously measured in the evaluation section; the active challenge is available whenever a stronger, interactive proof is warranted, without adding new hardware or a new channel.</a:t>
-            </a:r>
-          </a:p>
-        </p:txBody>
-      </p:sp>
-      <p:sp>
-        <p:nvSpPr>
-          <p:cNvPr id="4" name="Slide Number Placeholder 3"/>
-          <p:cNvSpPr>
-            <a:spLocks noGrp="1"/>
-          </p:cNvSpPr>
-          <p:nvPr>
-            <p:ph type="sldNum" sz="quarter" idx="5"/>
-          </p:nvPr>
-        </p:nvSpPr>
-        <p:spPr/>
-      </p:sp>
-    </p:spTree>
-  </p:cSld>
-  <p:clrMapOvr>
-    <a:masterClrMapping/>
-  </p:clrMapOvr>
-</p:notes>
-</file>
-
 <file path=ppt/notesSlides/notesSlide14.xml><?xml version="1.0" encoding="utf-8"?>
 <p:notes xmlns:a="http://schemas.openxmlformats.org/drawingml/2006/main" xmlns:r="http://schemas.openxmlformats.org/officeDocument/2006/relationships" xmlns:p="http://schemas.openxmlformats.org/presentationml/2006/main">
   <p:cSld>
@@ -1551,7 +1481,7 @@
           <a:lstStyle/>
           <a:p>
             <a:r>
-              <a:t>This closes the loop back to slide 10's scorecard, now with evidence in the last column instead of just mechanism. Read it goal by goal, evidence-first: this is the moment to sound confident, because everything in the 'evidence' column is a number you already showed them on the previous four slides — you're not introducing anything new here, just tying it together.</a:t>
+              <a:t>This closes the loop back to the Security Goals G1-G4 scorecard slide, now with evidence in the last column instead of just mechanism. Read it goal by goal, evidence-first: this is the moment to sound confident, because everything in the 'evidence' column is a number you already showed them on the previous four slides — you're not introducing anything new here, just tying it together.</a:t>
             </a:r>
           </a:p>
         </p:txBody>
@@ -2380,76 +2310,6 @@
           <a:p>
             <a:r>
               <a:t>Memorize this slide's content, don't read it verbatim in the room — but have it exact in your head. The tightest one-sentence version if you need to compress under time pressure: freshness answers 'is this new,' relay-bounding answers 'how long did this take to get here,' and this system only answers the first question.</a:t>
-            </a:r>
-          </a:p>
-        </p:txBody>
-      </p:sp>
-      <p:sp>
-        <p:nvSpPr>
-          <p:cNvPr id="4" name="Slide Number Placeholder 3"/>
-          <p:cNvSpPr>
-            <a:spLocks noGrp="1"/>
-          </p:cNvSpPr>
-          <p:nvPr>
-            <p:ph type="sldNum" sz="quarter" idx="5"/>
-          </p:nvPr>
-        </p:nvSpPr>
-        <p:spPr/>
-      </p:sp>
-    </p:spTree>
-  </p:cSld>
-  <p:clrMapOvr>
-    <a:masterClrMapping/>
-  </p:clrMapOvr>
-</p:notes>
-</file>
-
-<file path=ppt/notesSlides/notesSlide36.xml><?xml version="1.0" encoding="utf-8"?>
-<p:notes xmlns:a="http://schemas.openxmlformats.org/drawingml/2006/main" xmlns:r="http://schemas.openxmlformats.org/officeDocument/2006/relationships" xmlns:p="http://schemas.openxmlformats.org/presentationml/2006/main">
-  <p:cSld>
-    <p:spTree>
-      <p:nvGrpSpPr>
-        <p:cNvPr id="1" name=""/>
-        <p:cNvGrpSpPr/>
-        <p:nvPr/>
-      </p:nvGrpSpPr>
-      <p:grpSpPr>
-        <a:xfrm>
-          <a:off x="0" y="0"/>
-          <a:ext cx="0" cy="0"/>
-          <a:chOff x="0" y="0"/>
-          <a:chExt cx="0" cy="0"/>
-        </a:xfrm>
-      </p:grpSpPr>
-      <p:sp>
-        <p:nvSpPr>
-          <p:cNvPr id="2" name="Slide Image Placeholder 1"/>
-          <p:cNvSpPr>
-            <a:spLocks noGrp="1" noRot="1" noChangeAspect="1"/>
-          </p:cNvSpPr>
-          <p:nvPr>
-            <p:ph type="sldImg" idx="2"/>
-          </p:nvPr>
-        </p:nvSpPr>
-        <p:spPr/>
-      </p:sp>
-      <p:sp>
-        <p:nvSpPr>
-          <p:cNvPr id="3" name="Notes Placeholder 2"/>
-          <p:cNvSpPr>
-            <a:spLocks noGrp="1"/>
-          </p:cNvSpPr>
-          <p:nvPr>
-            <p:ph type="body" sz="quarter" idx="3"/>
-          </p:nvPr>
-        </p:nvSpPr>
-        <p:spPr/>
-        <p:txBody>
-          <a:bodyPr/>
-          <a:lstStyle/>
-          <a:p>
-            <a:r>
-              <a:t>Only needed if asked to justify why three separate receiver binaries exist rather than one. The honest answer: they correspond to three different Auth interaction models that were useful to isolate during development and evaluation — a proactive key-manager, a full combined session app, and a pure discovery/roaming client — not three independent implementations of the security logic, which is shared underneath via the same SST C API and the same replay/freshness code paths.</a:t>
             </a:r>
           </a:p>
         </p:txBody>
@@ -10971,8 +10831,8 @@
         </p:nvSpPr>
         <p:spPr>
           <a:xfrm>
-            <a:off x="502920" y="801303"/>
-            <a:ext cx="11155680" cy="822960"/>
+            <a:off x="533400" y="777240"/>
+            <a:ext cx="11155680" cy="538609"/>
           </a:xfrm>
           <a:prstGeom prst="rect">
             <a:avLst/>
@@ -10986,47 +10846,240 @@
           <a:lstStyle/>
           <a:p>
             <a:r>
-              <a:rPr sz="2900" b="1" dirty="0">
+              <a:rPr lang="en-US" sz="2900" b="1" dirty="0">
                 <a:solidFill>
                   <a:srgbClr val="0B0B0B"/>
                 </a:solidFill>
                 <a:latin typeface="Calibri"/>
               </a:rPr>
-              <a:t>Auth's Role Doesn't Stop After Provisioning</a:t>
-            </a:r>
-          </a:p>
-        </p:txBody>
-      </p:sp>
-      <p:pic>
-        <p:nvPicPr>
-          <p:cNvPr id="3" name="Picture 2" descr="sst_auth_role.png"/>
-          <p:cNvPicPr>
-            <a:picLocks noChangeAspect="1"/>
-          </p:cNvPicPr>
+              <a:t>Protocol Flow — Beacon to Authorization Grant</a:t>
+            </a:r>
+          </a:p>
+        </p:txBody>
+      </p:sp>
+      <p:sp>
+        <p:nvSpPr>
+          <p:cNvPr id="3" name="TextBox 2"/>
+          <p:cNvSpPr txBox="1"/>
           <p:nvPr/>
-        </p:nvPicPr>
-        <p:blipFill>
-          <a:blip r:embed="rId3"/>
-          <a:stretch>
-            <a:fillRect/>
-          </a:stretch>
-        </p:blipFill>
+        </p:nvSpPr>
         <p:spPr>
           <a:xfrm>
-            <a:off x="2818295" y="1417320"/>
-            <a:ext cx="6555105" cy="5074920"/>
+            <a:off x="502920" y="1299300"/>
+            <a:ext cx="11155680" cy="300082"/>
           </a:xfrm>
           <a:prstGeom prst="rect">
             <a:avLst/>
           </a:prstGeom>
+          <a:noFill/>
         </p:spPr>
-      </p:pic>
+        <p:txBody>
+          <a:bodyPr wrap="square">
+            <a:spAutoFit/>
+          </a:bodyPr>
+          <a:lstStyle/>
+          <a:p>
+            <a:r>
+              <a:rPr lang="en-US" sz="1350" i="1" dirty="0">
+                <a:solidFill>
+                  <a:srgbClr val="898781"/>
+                </a:solidFill>
+                <a:latin typeface="Calibri"/>
+              </a:rPr>
+              <a:t>One authorization round: what crosses the optical link, what crosses the network, and what Auth decides.</a:t>
+            </a:r>
+          </a:p>
+        </p:txBody>
+      </p:sp>
+      <p:sp>
+        <p:nvSpPr>
+          <p:cNvPr id="4" name="TextBox 3"/>
+          <p:cNvSpPr txBox="1"/>
+          <p:nvPr/>
+        </p:nvSpPr>
+        <p:spPr>
+          <a:xfrm>
+            <a:off x="685800" y="1600200"/>
+            <a:ext cx="10789920" cy="3452227"/>
+          </a:xfrm>
+          <a:prstGeom prst="rect">
+            <a:avLst/>
+          </a:prstGeom>
+          <a:noFill/>
+        </p:spPr>
+        <p:txBody>
+          <a:bodyPr wrap="square">
+            <a:spAutoFit/>
+          </a:bodyPr>
+          <a:lstStyle/>
+          <a:p>
+            <a:pPr marL="228600" indent="-228600">
+              <a:spcAft>
+                <a:spcPts val="300"/>
+              </a:spcAft>
+            </a:pPr>
+            <a:r>
+              <a:rPr lang="en-US" sz="1700" dirty="0">
+                <a:solidFill>
+                  <a:srgbClr val="0B0B0B"/>
+                </a:solidFill>
+                <a:latin typeface="Calibri"/>
+              </a:rPr>
+              <a:t>①  Beacon → Device (optical, one-way)</a:t>
+            </a:r>
+          </a:p>
+          <a:p>
+            <a:pPr marL="685800" lvl="1" indent="-228600">
+              <a:spcAft>
+                <a:spcPts val="1300"/>
+              </a:spcAft>
+            </a:pPr>
+            <a:r>
+              <a:rPr lang="en-US" sz="1500" dirty="0">
+                <a:solidFill>
+                  <a:srgbClr val="52514E"/>
+                </a:solidFill>
+                <a:latin typeface="Calibri"/>
+              </a:rPr>
+              <a:t>Sender broadcasts signed beacon B = { room_id, nonce N, timestamp t, MAC_k(·) } over the LED at fixed interval.</a:t>
+            </a:r>
+          </a:p>
+          <a:p>
+            <a:pPr marL="228600" indent="-228600">
+              <a:spcAft>
+                <a:spcPts val="300"/>
+              </a:spcAft>
+            </a:pPr>
+            <a:r>
+              <a:rPr lang="en-US" sz="1700" dirty="0">
+                <a:solidFill>
+                  <a:srgbClr val="0B0B0B"/>
+                </a:solidFill>
+                <a:latin typeface="Calibri"/>
+              </a:rPr>
+              <a:t>②  Device → Auth (network)</a:t>
+            </a:r>
+          </a:p>
+          <a:p>
+            <a:pPr marL="685800" lvl="1" indent="-228600">
+              <a:spcAft>
+                <a:spcPts val="1300"/>
+              </a:spcAft>
+            </a:pPr>
+            <a:r>
+              <a:rPr lang="en-US" sz="1500" dirty="0">
+                <a:solidFill>
+                  <a:srgbClr val="52514E"/>
+                </a:solidFill>
+                <a:latin typeface="Calibri"/>
+              </a:rPr>
+              <a:t>Device forwards the beacon it observed plus its own identity; it cannot forge N because it never held k.</a:t>
+            </a:r>
+          </a:p>
+          <a:p>
+            <a:pPr marL="228600" indent="-228600">
+              <a:spcAft>
+                <a:spcPts val="300"/>
+              </a:spcAft>
+            </a:pPr>
+            <a:r>
+              <a:rPr lang="en-US" sz="1700" dirty="0">
+                <a:solidFill>
+                  <a:srgbClr val="0B0B0B"/>
+                </a:solidFill>
+                <a:latin typeface="Calibri"/>
+              </a:rPr>
+              <a:t>③  Auth validates freshness and origin</a:t>
+            </a:r>
+          </a:p>
+          <a:p>
+            <a:pPr marL="685800" lvl="1" indent="-228600">
+              <a:spcAft>
+                <a:spcPts val="1300"/>
+              </a:spcAft>
+            </a:pPr>
+            <a:r>
+              <a:rPr lang="en-US" sz="1500" dirty="0">
+                <a:solidFill>
+                  <a:srgbClr val="52514E"/>
+                </a:solidFill>
+                <a:latin typeface="Calibri"/>
+              </a:rPr>
+              <a:t>Checks MAC under the sender's rotating key, then checks t is inside the acceptance window W and N is unseen.</a:t>
+            </a:r>
+          </a:p>
+          <a:p>
+            <a:pPr marL="228600" indent="-228600">
+              <a:spcAft>
+                <a:spcPts val="300"/>
+              </a:spcAft>
+            </a:pPr>
+            <a:r>
+              <a:rPr lang="en-US" sz="1700" dirty="0">
+                <a:solidFill>
+                  <a:srgbClr val="0B0B0B"/>
+                </a:solidFill>
+                <a:latin typeface="Calibri"/>
+              </a:rPr>
+              <a:t>④  Auth → Device: session credential</a:t>
+            </a:r>
+          </a:p>
+          <a:p>
+            <a:pPr marL="685800" lvl="1" indent="-228600">
+              <a:spcAft>
+                <a:spcPts val="1300"/>
+              </a:spcAft>
+            </a:pPr>
+            <a:r>
+              <a:rPr lang="en-US" sz="1500" dirty="0">
+                <a:solidFill>
+                  <a:srgbClr val="52514E"/>
+                </a:solidFill>
+                <a:latin typeface="Calibri"/>
+              </a:rPr>
+              <a:t>On success, Auth issues a short-lived SST session key scoped to room_id — physical presence becomes an access decision.</a:t>
+            </a:r>
+          </a:p>
+          <a:p>
+            <a:pPr marL="228600" indent="-228600">
+              <a:spcAft>
+                <a:spcPts val="300"/>
+              </a:spcAft>
+            </a:pPr>
+            <a:r>
+              <a:rPr lang="en-US" sz="1700" dirty="0">
+                <a:solidFill>
+                  <a:srgbClr val="0B0B0B"/>
+                </a:solidFill>
+                <a:latin typeface="Calibri"/>
+              </a:rPr>
+              <a:t>⑤  Continuous re-attestation</a:t>
+            </a:r>
+          </a:p>
+          <a:p>
+            <a:pPr marL="685800" lvl="1" indent="-228600">
+              <a:spcAft>
+                <a:spcPts val="1300"/>
+              </a:spcAft>
+            </a:pPr>
+            <a:r>
+              <a:rPr lang="en-US" sz="1500" dirty="0">
+                <a:solidFill>
+                  <a:srgbClr val="52514E"/>
+                </a:solidFill>
+                <a:latin typeface="Calibri"/>
+              </a:rPr>
+              <a:t>Device must present a fresh beacon each interval; on occlusion the credential expires rather than being revoked (see G4).</a:t>
+            </a:r>
+          </a:p>
+        </p:txBody>
+      </p:sp>
       <p:pic>
         <p:nvPicPr>
-          <p:cNvPr id="4" name="Picture 3" descr="A white background with text&#10;&#10;AI-generated content may be incorrect.">
+          <p:cNvPr id="7" name="Picture 6" descr="A white background with text&#10;&#10;AI-generated content may be incorrect.">
             <a:extLst>
               <a:ext uri="{FF2B5EF4-FFF2-40B4-BE49-F238E27FC236}">
-                <a16:creationId xmlns:a16="http://schemas.microsoft.com/office/drawing/2014/main" id="{842F10B3-DB57-3EBF-10AD-BD6C1B2514DF}"/>
+                <a16:creationId xmlns:a16="http://schemas.microsoft.com/office/drawing/2014/main" id="{E815CBF9-8B4C-C24C-1249-0A42B9A5F6CF}"/>
               </a:ext>
             </a:extLst>
           </p:cNvPr>
@@ -11036,7 +11089,7 @@
           <p:nvPr/>
         </p:nvPicPr>
         <p:blipFill>
-          <a:blip r:embed="rId4"/>
+          <a:blip r:embed="rId3"/>
           <a:stretch>
             <a:fillRect/>
           </a:stretch>
@@ -11053,10 +11106,10 @@
       </p:pic>
       <p:sp>
         <p:nvSpPr>
-          <p:cNvPr id="5" name="Rectangle 4">
+          <p:cNvPr id="8" name="Rectangle 7">
             <a:extLst>
               <a:ext uri="{FF2B5EF4-FFF2-40B4-BE49-F238E27FC236}">
-                <a16:creationId xmlns:a16="http://schemas.microsoft.com/office/drawing/2014/main" id="{A9039314-DA31-4692-9C1D-F224572C01CF}"/>
+                <a16:creationId xmlns:a16="http://schemas.microsoft.com/office/drawing/2014/main" id="{1D78EB68-6E49-6E62-6807-621A767964CE}"/>
               </a:ext>
             </a:extLst>
           </p:cNvPr>
@@ -11113,6 +11166,11 @@
         </p:txBody>
       </p:sp>
     </p:spTree>
+    <p:extLst>
+      <p:ext uri="{BB962C8B-B14F-4D97-AF65-F5344CB8AC3E}">
+        <p14:creationId xmlns:p14="http://schemas.microsoft.com/office/powerpoint/2010/main" val="3542443293"/>
+      </p:ext>
+    </p:extLst>
   </p:cSld>
   <p:clrMapOvr>
     <a:masterClrMapping/>
@@ -11153,8 +11211,8 @@
         </p:nvSpPr>
         <p:spPr>
           <a:xfrm>
-            <a:off x="533400" y="777240"/>
-            <a:ext cx="11155680" cy="538609"/>
+            <a:off x="518160" y="1003300"/>
+            <a:ext cx="11155680" cy="822960"/>
           </a:xfrm>
           <a:prstGeom prst="rect">
             <a:avLst/>
@@ -11168,13 +11226,13 @@
           <a:lstStyle/>
           <a:p>
             <a:r>
-              <a:rPr lang="en-US" sz="2900" b="1" dirty="0">
+              <a:rPr sz="2900" b="1" dirty="0">
                 <a:solidFill>
                   <a:srgbClr val="0B0B0B"/>
                 </a:solidFill>
                 <a:latin typeface="Calibri"/>
               </a:rPr>
-              <a:t>Protocol Flow — Beacon to Authorization Grant</a:t>
+              <a:t>Adversary Model</a:t>
             </a:r>
           </a:p>
         </p:txBody>
@@ -11187,8 +11245,8 @@
         </p:nvSpPr>
         <p:spPr>
           <a:xfrm>
-            <a:off x="502920" y="1299300"/>
-            <a:ext cx="11155680" cy="300082"/>
+            <a:off x="701040" y="1838960"/>
+            <a:ext cx="10789920" cy="4572000"/>
           </a:xfrm>
           <a:prstGeom prst="rect">
             <a:avLst/>
@@ -11201,207 +11259,109 @@
           </a:bodyPr>
           <a:lstStyle/>
           <a:p>
-            <a:r>
-              <a:rPr lang="en-US" sz="1350" i="1" dirty="0">
-                <a:solidFill>
-                  <a:srgbClr val="898781"/>
-                </a:solidFill>
-                <a:latin typeface="Calibri"/>
-              </a:rPr>
-              <a:t>One authorization round: what crosses the optical link, what crosses the network, and what Auth decides.</a:t>
-            </a:r>
-          </a:p>
-        </p:txBody>
-      </p:sp>
-      <p:sp>
-        <p:nvSpPr>
-          <p:cNvPr id="4" name="TextBox 3"/>
-          <p:cNvSpPr txBox="1"/>
-          <p:nvPr/>
-        </p:nvSpPr>
-        <p:spPr>
-          <a:xfrm>
-            <a:off x="685800" y="1600200"/>
-            <a:ext cx="10789920" cy="3452227"/>
-          </a:xfrm>
-          <a:prstGeom prst="rect">
-            <a:avLst/>
-          </a:prstGeom>
-          <a:noFill/>
-        </p:spPr>
-        <p:txBody>
-          <a:bodyPr wrap="square">
-            <a:spAutoFit/>
-          </a:bodyPr>
-          <a:lstStyle/>
-          <a:p>
-            <a:pPr marL="228600" indent="-228600">
+            <a:pPr>
               <a:spcAft>
-                <a:spcPts val="300"/>
+                <a:spcPts val="1100"/>
               </a:spcAft>
             </a:pPr>
             <a:r>
-              <a:rPr lang="en-US" sz="1700" dirty="0">
+              <a:rPr sz="1700" dirty="0">
                 <a:solidFill>
                   <a:srgbClr val="0B0B0B"/>
                 </a:solidFill>
                 <a:latin typeface="Calibri"/>
               </a:rPr>
-              <a:t>①  Beacon → Device (optical, one-way)</a:t>
-            </a:r>
-          </a:p>
-          <a:p>
-            <a:pPr marL="685800" lvl="1" indent="-228600">
+              <a:t>●   Network control — standard Dolev-Yao adversary on RF/network links (eavesdrop, replay, delay, drop, inject)</a:t>
+            </a:r>
+          </a:p>
+          <a:p>
+            <a:pPr>
               <a:spcAft>
-                <a:spcPts val="1300"/>
+                <a:spcPts val="1100"/>
               </a:spcAft>
             </a:pPr>
             <a:r>
-              <a:rPr lang="en-US" sz="1500" dirty="0">
-                <a:solidFill>
-                  <a:srgbClr val="52514E"/>
+              <a:rPr sz="1700" dirty="0">
+                <a:solidFill>
+                  <a:srgbClr val="0B0B0B"/>
                 </a:solidFill>
                 <a:latin typeface="Calibri"/>
               </a:rPr>
-              <a:t>Sender broadcasts signed beacon B = { room_id, nonce N, timestamp t, MAC_k(·) } over the LED at fixed interval.</a:t>
-            </a:r>
-          </a:p>
-          <a:p>
-            <a:pPr marL="228600" indent="-228600">
+              <a:t>●   Optical observation — passive sensors capture ciphertext, tags, nonces — never plaintext or key material</a:t>
+            </a:r>
+          </a:p>
+          <a:p>
+            <a:pPr>
               <a:spcAft>
-                <a:spcPts val="300"/>
+                <a:spcPts val="1100"/>
               </a:spcAft>
             </a:pPr>
             <a:r>
-              <a:rPr lang="en-US" sz="1700" dirty="0">
+              <a:rPr sz="1700" dirty="0">
                 <a:solidFill>
                   <a:srgbClr val="0B0B0B"/>
                 </a:solidFill>
                 <a:latin typeface="Calibri"/>
               </a:rPr>
-              <a:t>②  Device → Auth (network)</a:t>
-            </a:r>
-          </a:p>
-          <a:p>
-            <a:pPr marL="685800" lvl="1" indent="-228600">
+              <a:t>●   Relay — capture the optical signal, transport it, re-emit remotely; introduces latency δᵣₑₗₐᵧ</a:t>
+            </a:r>
+          </a:p>
+          <a:p>
+            <a:pPr>
               <a:spcAft>
-                <a:spcPts val="1300"/>
+                <a:spcPts val="1100"/>
               </a:spcAft>
             </a:pPr>
             <a:r>
-              <a:rPr lang="en-US" sz="1500" dirty="0">
-                <a:solidFill>
-                  <a:srgbClr val="52514E"/>
+              <a:rPr sz="1700" dirty="0">
+                <a:solidFill>
+                  <a:srgbClr val="0B0B0B"/>
                 </a:solidFill>
                 <a:latin typeface="Calibri"/>
               </a:rPr>
-              <a:t>Device forwards the beacon it observed plus its own identity; it cannot forge N because it never held k.</a:t>
-            </a:r>
-          </a:p>
-          <a:p>
-            <a:pPr marL="228600" indent="-228600">
+              <a:t>●   Optical injection — a rogue light source without the session key fails AES-128-GCM tag verification</a:t>
+            </a:r>
+          </a:p>
+          <a:p>
+            <a:pPr>
               <a:spcAft>
-                <a:spcPts val="300"/>
+                <a:spcPts val="1100"/>
               </a:spcAft>
             </a:pPr>
             <a:r>
-              <a:rPr lang="en-US" sz="1700" dirty="0">
+              <a:rPr sz="1700" dirty="0">
                 <a:solidFill>
                   <a:srgbClr val="0B0B0B"/>
                 </a:solidFill>
                 <a:latin typeface="Calibri"/>
               </a:rPr>
-              <a:t>③  Auth validates freshness and origin</a:t>
-            </a:r>
-          </a:p>
-          <a:p>
-            <a:pPr marL="685800" lvl="1" indent="-228600">
+              <a:t>●   Denial of service — physical obstruction, ambient-light saturation, RF jamming of the network link</a:t>
+            </a:r>
+          </a:p>
+          <a:p>
+            <a:pPr lvl="1">
               <a:spcAft>
-                <a:spcPts val="1300"/>
+                <a:spcPts val="700"/>
               </a:spcAft>
             </a:pPr>
             <a:r>
-              <a:rPr lang="en-US" sz="1500" dirty="0">
+              <a:rPr sz="1450" dirty="0">
                 <a:solidFill>
                   <a:srgbClr val="52514E"/>
                 </a:solidFill>
                 <a:latin typeface="Calibri"/>
               </a:rPr>
-              <a:t>Checks MAC under the sender's rotating key, then checks t is inside the acceptance window W and N is unseen.</a:t>
-            </a:r>
-          </a:p>
-          <a:p>
-            <a:pPr marL="228600" indent="-228600">
-              <a:spcAft>
-                <a:spcPts val="300"/>
-              </a:spcAft>
-            </a:pPr>
-            <a:r>
-              <a:rPr lang="en-US" sz="1700" dirty="0">
-                <a:solidFill>
-                  <a:srgbClr val="0B0B0B"/>
-                </a:solidFill>
-                <a:latin typeface="Calibri"/>
-              </a:rPr>
-              <a:t>④  Auth → Device: session credential</a:t>
-            </a:r>
-          </a:p>
-          <a:p>
-            <a:pPr marL="685800" lvl="1" indent="-228600">
-              <a:spcAft>
-                <a:spcPts val="1300"/>
-              </a:spcAft>
-            </a:pPr>
-            <a:r>
-              <a:rPr lang="en-US" sz="1500" dirty="0">
-                <a:solidFill>
-                  <a:srgbClr val="52514E"/>
-                </a:solidFill>
-                <a:latin typeface="Calibri"/>
-              </a:rPr>
-              <a:t>On success, Auth issues a short-lived SST session key scoped to room_id — physical presence becomes an access decision.</a:t>
-            </a:r>
-          </a:p>
-          <a:p>
-            <a:pPr marL="228600" indent="-228600">
-              <a:spcAft>
-                <a:spcPts val="300"/>
-              </a:spcAft>
-            </a:pPr>
-            <a:r>
-              <a:rPr lang="en-US" sz="1700" dirty="0">
-                <a:solidFill>
-                  <a:srgbClr val="0B0B0B"/>
-                </a:solidFill>
-                <a:latin typeface="Calibri"/>
-              </a:rPr>
-              <a:t>⑤  Continuous re-attestation</a:t>
-            </a:r>
-          </a:p>
-          <a:p>
-            <a:pPr marL="685800" lvl="1" indent="-228600">
-              <a:spcAft>
-                <a:spcPts val="1300"/>
-              </a:spcAft>
-            </a:pPr>
-            <a:r>
-              <a:rPr lang="en-US" sz="1500" dirty="0">
-                <a:solidFill>
-                  <a:srgbClr val="52514E"/>
-                </a:solidFill>
-                <a:latin typeface="Calibri"/>
-              </a:rPr>
-              <a:t>Device must present a fresh beacon each interval; on occlusion the credential expires rather than being revoked (see G4).</a:t>
+              <a:t>‒   The system fails closed by design: denial of signal → revocation, never false authorization</a:t>
             </a:r>
           </a:p>
         </p:txBody>
       </p:sp>
       <p:pic>
         <p:nvPicPr>
-          <p:cNvPr id="7" name="Picture 6" descr="A white background with text&#10;&#10;AI-generated content may be incorrect.">
+          <p:cNvPr id="4" name="Picture 3" descr="A white background with text&#10;&#10;AI-generated content may be incorrect.">
             <a:extLst>
               <a:ext uri="{FF2B5EF4-FFF2-40B4-BE49-F238E27FC236}">
-                <a16:creationId xmlns:a16="http://schemas.microsoft.com/office/drawing/2014/main" id="{E815CBF9-8B4C-C24C-1249-0A42B9A5F6CF}"/>
+                <a16:creationId xmlns:a16="http://schemas.microsoft.com/office/drawing/2014/main" id="{FEF72888-CE72-5ADB-6A05-EAED81B5D108}"/>
               </a:ext>
             </a:extLst>
           </p:cNvPr>
@@ -11428,10 +11388,10 @@
       </p:pic>
       <p:sp>
         <p:nvSpPr>
-          <p:cNvPr id="8" name="Rectangle 7">
+          <p:cNvPr id="5" name="Rectangle 4">
             <a:extLst>
               <a:ext uri="{FF2B5EF4-FFF2-40B4-BE49-F238E27FC236}">
-                <a16:creationId xmlns:a16="http://schemas.microsoft.com/office/drawing/2014/main" id="{1D78EB68-6E49-6E62-6807-621A767964CE}"/>
+                <a16:creationId xmlns:a16="http://schemas.microsoft.com/office/drawing/2014/main" id="{6B0403EE-BF2B-B038-5023-B1F39A4BEADE}"/>
               </a:ext>
             </a:extLst>
           </p:cNvPr>
@@ -11488,11 +11448,6 @@
         </p:txBody>
       </p:sp>
     </p:spTree>
-    <p:extLst>
-      <p:ext uri="{BB962C8B-B14F-4D97-AF65-F5344CB8AC3E}">
-        <p14:creationId xmlns:p14="http://schemas.microsoft.com/office/powerpoint/2010/main" val="3542443293"/>
-      </p:ext>
-    </p:extLst>
   </p:cSld>
   <p:clrMapOvr>
     <a:masterClrMapping/>
@@ -11501,283 +11456,6 @@
 </file>
 
 <file path=ppt/slides/slide15.xml><?xml version="1.0" encoding="utf-8"?>
-<p:sld xmlns:a="http://schemas.openxmlformats.org/drawingml/2006/main" xmlns:r="http://schemas.openxmlformats.org/officeDocument/2006/relationships" xmlns:p="http://schemas.openxmlformats.org/presentationml/2006/main">
-  <p:cSld>
-    <p:bg>
-      <p:bgPr>
-        <a:solidFill>
-          <a:srgbClr val="FCFCFB"/>
-        </a:solidFill>
-        <a:effectLst/>
-      </p:bgPr>
-    </p:bg>
-    <p:spTree>
-      <p:nvGrpSpPr>
-        <p:cNvPr id="1" name=""/>
-        <p:cNvGrpSpPr/>
-        <p:nvPr/>
-      </p:nvGrpSpPr>
-      <p:grpSpPr>
-        <a:xfrm>
-          <a:off x="0" y="0"/>
-          <a:ext cx="0" cy="0"/>
-          <a:chOff x="0" y="0"/>
-          <a:chExt cx="0" cy="0"/>
-        </a:xfrm>
-      </p:grpSpPr>
-      <p:sp>
-        <p:nvSpPr>
-          <p:cNvPr id="2" name="TextBox 1"/>
-          <p:cNvSpPr txBox="1"/>
-          <p:nvPr/>
-        </p:nvSpPr>
-        <p:spPr>
-          <a:xfrm>
-            <a:off x="518160" y="1003300"/>
-            <a:ext cx="11155680" cy="822960"/>
-          </a:xfrm>
-          <a:prstGeom prst="rect">
-            <a:avLst/>
-          </a:prstGeom>
-          <a:noFill/>
-        </p:spPr>
-        <p:txBody>
-          <a:bodyPr wrap="square">
-            <a:spAutoFit/>
-          </a:bodyPr>
-          <a:lstStyle/>
-          <a:p>
-            <a:r>
-              <a:rPr sz="2900" b="1" dirty="0">
-                <a:solidFill>
-                  <a:srgbClr val="0B0B0B"/>
-                </a:solidFill>
-                <a:latin typeface="Calibri"/>
-              </a:rPr>
-              <a:t>Adversary Model</a:t>
-            </a:r>
-          </a:p>
-        </p:txBody>
-      </p:sp>
-      <p:sp>
-        <p:nvSpPr>
-          <p:cNvPr id="3" name="TextBox 2"/>
-          <p:cNvSpPr txBox="1"/>
-          <p:nvPr/>
-        </p:nvSpPr>
-        <p:spPr>
-          <a:xfrm>
-            <a:off x="701040" y="1838960"/>
-            <a:ext cx="10789920" cy="4572000"/>
-          </a:xfrm>
-          <a:prstGeom prst="rect">
-            <a:avLst/>
-          </a:prstGeom>
-          <a:noFill/>
-        </p:spPr>
-        <p:txBody>
-          <a:bodyPr wrap="square">
-            <a:spAutoFit/>
-          </a:bodyPr>
-          <a:lstStyle/>
-          <a:p>
-            <a:pPr>
-              <a:spcAft>
-                <a:spcPts val="1100"/>
-              </a:spcAft>
-            </a:pPr>
-            <a:r>
-              <a:rPr sz="1700" dirty="0">
-                <a:solidFill>
-                  <a:srgbClr val="0B0B0B"/>
-                </a:solidFill>
-                <a:latin typeface="Calibri"/>
-              </a:rPr>
-              <a:t>●   Network control — standard Dolev-Yao adversary on RF/network links (eavesdrop, replay, delay, drop, inject)</a:t>
-            </a:r>
-          </a:p>
-          <a:p>
-            <a:pPr>
-              <a:spcAft>
-                <a:spcPts val="1100"/>
-              </a:spcAft>
-            </a:pPr>
-            <a:r>
-              <a:rPr sz="1700" dirty="0">
-                <a:solidFill>
-                  <a:srgbClr val="0B0B0B"/>
-                </a:solidFill>
-                <a:latin typeface="Calibri"/>
-              </a:rPr>
-              <a:t>●   Optical observation — passive sensors capture ciphertext, tags, nonces — never plaintext or key material</a:t>
-            </a:r>
-          </a:p>
-          <a:p>
-            <a:pPr>
-              <a:spcAft>
-                <a:spcPts val="1100"/>
-              </a:spcAft>
-            </a:pPr>
-            <a:r>
-              <a:rPr sz="1700" dirty="0">
-                <a:solidFill>
-                  <a:srgbClr val="0B0B0B"/>
-                </a:solidFill>
-                <a:latin typeface="Calibri"/>
-              </a:rPr>
-              <a:t>●   Relay — capture the optical signal, transport it, re-emit remotely; introduces latency δᵣₑₗₐᵧ</a:t>
-            </a:r>
-          </a:p>
-          <a:p>
-            <a:pPr>
-              <a:spcAft>
-                <a:spcPts val="1100"/>
-              </a:spcAft>
-            </a:pPr>
-            <a:r>
-              <a:rPr sz="1700" dirty="0">
-                <a:solidFill>
-                  <a:srgbClr val="0B0B0B"/>
-                </a:solidFill>
-                <a:latin typeface="Calibri"/>
-              </a:rPr>
-              <a:t>●   Optical injection — a rogue light source without the session key fails AES-128-GCM tag verification</a:t>
-            </a:r>
-          </a:p>
-          <a:p>
-            <a:pPr>
-              <a:spcAft>
-                <a:spcPts val="1100"/>
-              </a:spcAft>
-            </a:pPr>
-            <a:r>
-              <a:rPr sz="1700" dirty="0">
-                <a:solidFill>
-                  <a:srgbClr val="0B0B0B"/>
-                </a:solidFill>
-                <a:latin typeface="Calibri"/>
-              </a:rPr>
-              <a:t>●   Denial of service — physical obstruction, ambient-light saturation, RF jamming of the network link</a:t>
-            </a:r>
-          </a:p>
-          <a:p>
-            <a:pPr lvl="1">
-              <a:spcAft>
-                <a:spcPts val="700"/>
-              </a:spcAft>
-            </a:pPr>
-            <a:r>
-              <a:rPr sz="1450" dirty="0">
-                <a:solidFill>
-                  <a:srgbClr val="52514E"/>
-                </a:solidFill>
-                <a:latin typeface="Calibri"/>
-              </a:rPr>
-              <a:t>‒   The system fails closed by design: denial of signal → revocation, never false authorization</a:t>
-            </a:r>
-          </a:p>
-        </p:txBody>
-      </p:sp>
-      <p:pic>
-        <p:nvPicPr>
-          <p:cNvPr id="4" name="Picture 3" descr="A white background with text&#10;&#10;AI-generated content may be incorrect.">
-            <a:extLst>
-              <a:ext uri="{FF2B5EF4-FFF2-40B4-BE49-F238E27FC236}">
-                <a16:creationId xmlns:a16="http://schemas.microsoft.com/office/drawing/2014/main" id="{FEF72888-CE72-5ADB-6A05-EAED81B5D108}"/>
-              </a:ext>
-            </a:extLst>
-          </p:cNvPr>
-          <p:cNvPicPr>
-            <a:picLocks noChangeAspect="1"/>
-          </p:cNvPicPr>
-          <p:nvPr/>
-        </p:nvPicPr>
-        <p:blipFill>
-          <a:blip r:embed="rId3"/>
-          <a:stretch>
-            <a:fillRect/>
-          </a:stretch>
-        </p:blipFill>
-        <p:spPr>
-          <a:xfrm>
-            <a:off x="9545121" y="-4718"/>
-            <a:ext cx="2646879" cy="1477328"/>
-          </a:xfrm>
-          <a:prstGeom prst="rect">
-            <a:avLst/>
-          </a:prstGeom>
-        </p:spPr>
-      </p:pic>
-      <p:sp>
-        <p:nvSpPr>
-          <p:cNvPr id="5" name="Rectangle 4">
-            <a:extLst>
-              <a:ext uri="{FF2B5EF4-FFF2-40B4-BE49-F238E27FC236}">
-                <a16:creationId xmlns:a16="http://schemas.microsoft.com/office/drawing/2014/main" id="{6B0403EE-BF2B-B038-5023-B1F39A4BEADE}"/>
-              </a:ext>
-            </a:extLst>
-          </p:cNvPr>
-          <p:cNvSpPr/>
-          <p:nvPr/>
-        </p:nvSpPr>
-        <p:spPr>
-          <a:xfrm>
-            <a:off x="0" y="0"/>
-            <a:ext cx="9545121" cy="517206"/>
-          </a:xfrm>
-          <a:prstGeom prst="rect">
-            <a:avLst/>
-          </a:prstGeom>
-          <a:solidFill>
-            <a:srgbClr val="ECBE44"/>
-          </a:solidFill>
-          <a:ln>
-            <a:solidFill>
-              <a:schemeClr val="bg1"/>
-            </a:solidFill>
-          </a:ln>
-        </p:spPr>
-        <p:style>
-          <a:lnRef idx="2">
-            <a:schemeClr val="accent1">
-              <a:shade val="15000"/>
-            </a:schemeClr>
-          </a:lnRef>
-          <a:fillRef idx="1">
-            <a:schemeClr val="accent1"/>
-          </a:fillRef>
-          <a:effectRef idx="0">
-            <a:schemeClr val="accent1"/>
-          </a:effectRef>
-          <a:fontRef idx="minor">
-            <a:schemeClr val="lt1"/>
-          </a:fontRef>
-        </p:style>
-        <p:txBody>
-          <a:bodyPr rtlCol="0" anchor="ctr"/>
-          <a:lstStyle/>
-          <a:p>
-            <a:pPr algn="ctr"/>
-            <a:endParaRPr lang="en-US" dirty="0">
-              <a:solidFill>
-                <a:srgbClr val="FF0000"/>
-              </a:solidFill>
-              <a:highlight>
-                <a:srgbClr val="FFFF00"/>
-              </a:highlight>
-            </a:endParaRPr>
-          </a:p>
-        </p:txBody>
-      </p:sp>
-    </p:spTree>
-  </p:cSld>
-  <p:clrMapOvr>
-    <a:masterClrMapping/>
-  </p:clrMapOvr>
-</p:sld>
-</file>
-
-<file path=ppt/slides/slide16.xml><?xml version="1.0" encoding="utf-8"?>
 <p:sld xmlns:a="http://schemas.openxmlformats.org/drawingml/2006/main" xmlns:r="http://schemas.openxmlformats.org/officeDocument/2006/relationships" xmlns:p="http://schemas.openxmlformats.org/presentationml/2006/main">
   <p:cSld>
     <p:bg>
@@ -12517,7 +12195,7 @@
 </p:sld>
 </file>
 
-<file path=ppt/slides/slide17.xml><?xml version="1.0" encoding="utf-8"?>
+<file path=ppt/slides/slide16.xml><?xml version="1.0" encoding="utf-8"?>
 <p:sld xmlns:a="http://schemas.openxmlformats.org/drawingml/2006/main" xmlns:r="http://schemas.openxmlformats.org/officeDocument/2006/relationships" xmlns:p="http://schemas.openxmlformats.org/presentationml/2006/main">
   <p:cSld>
     <p:bg>
@@ -12794,7 +12472,7 @@
 </p:sld>
 </file>
 
-<file path=ppt/slides/slide18.xml><?xml version="1.0" encoding="utf-8"?>
+<file path=ppt/slides/slide17.xml><?xml version="1.0" encoding="utf-8"?>
 <p:sld xmlns:a="http://schemas.openxmlformats.org/drawingml/2006/main" xmlns:r="http://schemas.openxmlformats.org/officeDocument/2006/relationships" xmlns:p="http://schemas.openxmlformats.org/presentationml/2006/main">
   <p:cSld>
     <p:bg>
@@ -13011,7 +12689,7 @@
 </p:sld>
 </file>
 
-<file path=ppt/slides/slide19.xml><?xml version="1.0" encoding="utf-8"?>
+<file path=ppt/slides/slide18.xml><?xml version="1.0" encoding="utf-8"?>
 <p:sld xmlns:a="http://schemas.openxmlformats.org/drawingml/2006/main" xmlns:r="http://schemas.openxmlformats.org/officeDocument/2006/relationships" xmlns:p="http://schemas.openxmlformats.org/presentationml/2006/main">
   <p:cSld>
     <p:bg>
@@ -13165,6 +12843,240 @@
             <a:extLst>
               <a:ext uri="{FF2B5EF4-FFF2-40B4-BE49-F238E27FC236}">
                 <a16:creationId xmlns:a16="http://schemas.microsoft.com/office/drawing/2014/main" id="{9F7426EC-C6E5-1F3A-F7B8-66CBB09FC937}"/>
+              </a:ext>
+            </a:extLst>
+          </p:cNvPr>
+          <p:cNvSpPr/>
+          <p:nvPr/>
+        </p:nvSpPr>
+        <p:spPr>
+          <a:xfrm>
+            <a:off x="0" y="0"/>
+            <a:ext cx="9545121" cy="517206"/>
+          </a:xfrm>
+          <a:prstGeom prst="rect">
+            <a:avLst/>
+          </a:prstGeom>
+          <a:solidFill>
+            <a:srgbClr val="ECBE44"/>
+          </a:solidFill>
+          <a:ln>
+            <a:solidFill>
+              <a:schemeClr val="bg1"/>
+            </a:solidFill>
+          </a:ln>
+        </p:spPr>
+        <p:style>
+          <a:lnRef idx="2">
+            <a:schemeClr val="accent1">
+              <a:shade val="15000"/>
+            </a:schemeClr>
+          </a:lnRef>
+          <a:fillRef idx="1">
+            <a:schemeClr val="accent1"/>
+          </a:fillRef>
+          <a:effectRef idx="0">
+            <a:schemeClr val="accent1"/>
+          </a:effectRef>
+          <a:fontRef idx="minor">
+            <a:schemeClr val="lt1"/>
+          </a:fontRef>
+        </p:style>
+        <p:txBody>
+          <a:bodyPr rtlCol="0" anchor="ctr"/>
+          <a:lstStyle/>
+          <a:p>
+            <a:pPr algn="ctr"/>
+            <a:endParaRPr lang="en-US" dirty="0">
+              <a:solidFill>
+                <a:srgbClr val="FF0000"/>
+              </a:solidFill>
+              <a:highlight>
+                <a:srgbClr val="FFFF00"/>
+              </a:highlight>
+            </a:endParaRPr>
+          </a:p>
+        </p:txBody>
+      </p:sp>
+    </p:spTree>
+  </p:cSld>
+  <p:clrMapOvr>
+    <a:masterClrMapping/>
+  </p:clrMapOvr>
+</p:sld>
+</file>
+
+<file path=ppt/slides/slide19.xml><?xml version="1.0" encoding="utf-8"?>
+<p:sld xmlns:a="http://schemas.openxmlformats.org/drawingml/2006/main" xmlns:r="http://schemas.openxmlformats.org/officeDocument/2006/relationships" xmlns:p="http://schemas.openxmlformats.org/presentationml/2006/main">
+  <p:cSld>
+    <p:bg>
+      <p:bgPr>
+        <a:solidFill>
+          <a:srgbClr val="FCFCFB"/>
+        </a:solidFill>
+        <a:effectLst/>
+      </p:bgPr>
+    </p:bg>
+    <p:spTree>
+      <p:nvGrpSpPr>
+        <p:cNvPr id="1" name=""/>
+        <p:cNvGrpSpPr/>
+        <p:nvPr/>
+      </p:nvGrpSpPr>
+      <p:grpSpPr>
+        <a:xfrm>
+          <a:off x="0" y="0"/>
+          <a:ext cx="0" cy="0"/>
+          <a:chOff x="0" y="0"/>
+          <a:chExt cx="0" cy="0"/>
+        </a:xfrm>
+      </p:grpSpPr>
+      <p:sp>
+        <p:nvSpPr>
+          <p:cNvPr id="2" name="TextBox 1"/>
+          <p:cNvSpPr txBox="1"/>
+          <p:nvPr/>
+        </p:nvSpPr>
+        <p:spPr>
+          <a:xfrm>
+            <a:off x="518007" y="830179"/>
+            <a:ext cx="11155680" cy="984885"/>
+          </a:xfrm>
+          <a:prstGeom prst="rect">
+            <a:avLst/>
+          </a:prstGeom>
+          <a:noFill/>
+        </p:spPr>
+        <p:txBody>
+          <a:bodyPr wrap="square">
+            <a:spAutoFit/>
+          </a:bodyPr>
+          <a:lstStyle/>
+          <a:p>
+            <a:r>
+              <a:rPr sz="2900" b="1" dirty="0">
+                <a:solidFill>
+                  <a:srgbClr val="0B0B0B"/>
+                </a:solidFill>
+                <a:latin typeface="Calibri"/>
+              </a:rPr>
+              <a:t>G2 — Replay Rejection &amp; the Window-Boundary </a:t>
+            </a:r>
+            <a:endParaRPr lang="en-US" sz="2900" b="1" dirty="0">
+              <a:solidFill>
+                <a:srgbClr val="0B0B0B"/>
+              </a:solidFill>
+              <a:latin typeface="Calibri"/>
+            </a:endParaRPr>
+          </a:p>
+          <a:p>
+            <a:r>
+              <a:rPr sz="2900" b="1" dirty="0">
+                <a:solidFill>
+                  <a:srgbClr val="0B0B0B"/>
+                </a:solidFill>
+                <a:latin typeface="Calibri"/>
+              </a:rPr>
+              <a:t>Limitation</a:t>
+            </a:r>
+          </a:p>
+        </p:txBody>
+      </p:sp>
+      <p:pic>
+        <p:nvPicPr>
+          <p:cNvPr id="3" name="Picture 2" descr="replay_boundary.png"/>
+          <p:cNvPicPr>
+            <a:picLocks noChangeAspect="1"/>
+          </p:cNvPicPr>
+          <p:nvPr/>
+        </p:nvPicPr>
+        <p:blipFill>
+          <a:blip r:embed="rId3"/>
+          <a:stretch>
+            <a:fillRect/>
+          </a:stretch>
+        </p:blipFill>
+        <p:spPr>
+          <a:xfrm>
+            <a:off x="723747" y="1699815"/>
+            <a:ext cx="10744200" cy="4297680"/>
+          </a:xfrm>
+          <a:prstGeom prst="rect">
+            <a:avLst/>
+          </a:prstGeom>
+        </p:spPr>
+      </p:pic>
+      <p:sp>
+        <p:nvSpPr>
+          <p:cNvPr id="4" name="TextBox 3"/>
+          <p:cNvSpPr txBox="1"/>
+          <p:nvPr/>
+        </p:nvSpPr>
+        <p:spPr>
+          <a:xfrm>
+            <a:off x="502920" y="6013324"/>
+            <a:ext cx="11155680" cy="548640"/>
+          </a:xfrm>
+          <a:prstGeom prst="rect">
+            <a:avLst/>
+          </a:prstGeom>
+          <a:noFill/>
+        </p:spPr>
+        <p:txBody>
+          <a:bodyPr wrap="square">
+            <a:spAutoFit/>
+          </a:bodyPr>
+          <a:lstStyle/>
+          <a:p>
+            <a:pPr algn="ctr"/>
+            <a:r>
+              <a:rPr sz="1250" b="1" i="0">
+                <a:solidFill>
+                  <a:srgbClr val="898781"/>
+                </a:solidFill>
+                <a:latin typeface="Calibri"/>
+              </a:rPr>
+              <a:t>Immediate replay rejected; re-accepted only after eviction from a shrunk 2-slot window — reproduced 25/25 across independent automated trials.</a:t>
+            </a:r>
+          </a:p>
+        </p:txBody>
+      </p:sp>
+      <p:pic>
+        <p:nvPicPr>
+          <p:cNvPr id="5" name="Picture 4" descr="A white background with text&#10;&#10;AI-generated content may be incorrect.">
+            <a:extLst>
+              <a:ext uri="{FF2B5EF4-FFF2-40B4-BE49-F238E27FC236}">
+                <a16:creationId xmlns:a16="http://schemas.microsoft.com/office/drawing/2014/main" id="{0AFD44F8-8F5F-6BA3-85B4-745671AD1BE7}"/>
+              </a:ext>
+            </a:extLst>
+          </p:cNvPr>
+          <p:cNvPicPr>
+            <a:picLocks noChangeAspect="1"/>
+          </p:cNvPicPr>
+          <p:nvPr/>
+        </p:nvPicPr>
+        <p:blipFill>
+          <a:blip r:embed="rId4"/>
+          <a:stretch>
+            <a:fillRect/>
+          </a:stretch>
+        </p:blipFill>
+        <p:spPr>
+          <a:xfrm>
+            <a:off x="9545121" y="-4718"/>
+            <a:ext cx="2646879" cy="1477328"/>
+          </a:xfrm>
+          <a:prstGeom prst="rect">
+            <a:avLst/>
+          </a:prstGeom>
+        </p:spPr>
+      </p:pic>
+      <p:sp>
+        <p:nvSpPr>
+          <p:cNvPr id="6" name="Rectangle 5">
+            <a:extLst>
+              <a:ext uri="{FF2B5EF4-FFF2-40B4-BE49-F238E27FC236}">
+                <a16:creationId xmlns:a16="http://schemas.microsoft.com/office/drawing/2014/main" id="{0D6FB647-9E33-3425-3A75-61C3F4EE7A05}"/>
               </a:ext>
             </a:extLst>
           </p:cNvPr>
@@ -14080,8 +13992,8 @@
         </p:nvSpPr>
         <p:spPr>
           <a:xfrm>
-            <a:off x="518007" y="830179"/>
-            <a:ext cx="11155680" cy="984885"/>
+            <a:off x="518007" y="731520"/>
+            <a:ext cx="11155680" cy="822960"/>
           </a:xfrm>
           <a:prstGeom prst="rect">
             <a:avLst/>
@@ -14095,37 +14007,20 @@
           <a:lstStyle/>
           <a:p>
             <a:r>
-              <a:rPr sz="2900" b="1" dirty="0">
+              <a:rPr sz="2900" b="1">
                 <a:solidFill>
                   <a:srgbClr val="0B0B0B"/>
                 </a:solidFill>
                 <a:latin typeface="Calibri"/>
               </a:rPr>
-              <a:t>G2 — Replay Rejection &amp; the Window-Boundary </a:t>
-            </a:r>
-            <a:endParaRPr lang="en-US" sz="2900" b="1" dirty="0">
-              <a:solidFill>
-                <a:srgbClr val="0B0B0B"/>
-              </a:solidFill>
-              <a:latin typeface="Calibri"/>
-            </a:endParaRPr>
-          </a:p>
-          <a:p>
-            <a:r>
-              <a:rPr sz="2900" b="1" dirty="0">
-                <a:solidFill>
-                  <a:srgbClr val="0B0B0B"/>
-                </a:solidFill>
-                <a:latin typeface="Calibri"/>
-              </a:rPr>
-              <a:t>Limitation</a:t>
+              <a:t>Communication Performance</a:t>
             </a:r>
           </a:p>
         </p:txBody>
       </p:sp>
       <p:pic>
         <p:nvPicPr>
-          <p:cNvPr id="3" name="Picture 2" descr="replay_boundary.png"/>
+          <p:cNvPr id="3" name="Picture 2" descr="baud_sweep.png"/>
           <p:cNvPicPr>
             <a:picLocks noChangeAspect="1"/>
           </p:cNvPicPr>
@@ -14139,8 +14034,8 @@
         </p:blipFill>
         <p:spPr>
           <a:xfrm>
-            <a:off x="723747" y="1699815"/>
-            <a:ext cx="10744200" cy="4297680"/>
+            <a:off x="1107469" y="1417320"/>
+            <a:ext cx="9976757" cy="4297680"/>
           </a:xfrm>
           <a:prstGeom prst="rect">
             <a:avLst/>
@@ -14155,7 +14050,7 @@
         </p:nvSpPr>
         <p:spPr>
           <a:xfrm>
-            <a:off x="502920" y="6013324"/>
+            <a:off x="502920" y="5806440"/>
             <a:ext cx="11155680" cy="548640"/>
           </a:xfrm>
           <a:prstGeom prst="rect">
@@ -14177,7 +14072,7 @@
                 </a:solidFill>
                 <a:latin typeface="Calibri"/>
               </a:rPr>
-              <a:t>Immediate replay rejected; re-accepted only after eviction from a shrunk 2-slot window — reproduced 25/25 across independent automated trials.</a:t>
+              <a:t>Higher gain (470kΩ) beats higher bandwidth (100kΩ) at 15cm — SNR margin, not TIA bandwidth, limits close range.</a:t>
             </a:r>
           </a:p>
         </p:txBody>
@@ -14187,7 +14082,7 @@
           <p:cNvPr id="5" name="Picture 4" descr="A white background with text&#10;&#10;AI-generated content may be incorrect.">
             <a:extLst>
               <a:ext uri="{FF2B5EF4-FFF2-40B4-BE49-F238E27FC236}">
-                <a16:creationId xmlns:a16="http://schemas.microsoft.com/office/drawing/2014/main" id="{0AFD44F8-8F5F-6BA3-85B4-745671AD1BE7}"/>
+                <a16:creationId xmlns:a16="http://schemas.microsoft.com/office/drawing/2014/main" id="{261FC07C-93A2-0855-FB99-D948A27FD5A8}"/>
               </a:ext>
             </a:extLst>
           </p:cNvPr>
@@ -14217,7 +14112,7 @@
           <p:cNvPr id="6" name="Rectangle 5">
             <a:extLst>
               <a:ext uri="{FF2B5EF4-FFF2-40B4-BE49-F238E27FC236}">
-                <a16:creationId xmlns:a16="http://schemas.microsoft.com/office/drawing/2014/main" id="{0D6FB647-9E33-3425-3A75-61C3F4EE7A05}"/>
+                <a16:creationId xmlns:a16="http://schemas.microsoft.com/office/drawing/2014/main" id="{A1897D6F-97CB-D526-7BF3-AF37F4721B43}"/>
               </a:ext>
             </a:extLst>
           </p:cNvPr>
@@ -14314,8 +14209,8 @@
         </p:nvSpPr>
         <p:spPr>
           <a:xfrm>
-            <a:off x="518007" y="731520"/>
-            <a:ext cx="11155680" cy="822960"/>
+            <a:off x="533400" y="777240"/>
+            <a:ext cx="11155680" cy="538609"/>
           </a:xfrm>
           <a:prstGeom prst="rect">
             <a:avLst/>
@@ -14329,51 +14224,27 @@
           <a:lstStyle/>
           <a:p>
             <a:r>
-              <a:rPr sz="2900" b="1">
+              <a:rPr lang="en-US" sz="2900" b="1" dirty="0">
                 <a:solidFill>
                   <a:srgbClr val="0B0B0B"/>
                 </a:solidFill>
                 <a:latin typeface="Calibri"/>
               </a:rPr>
-              <a:t>Communication Performance</a:t>
-            </a:r>
-          </a:p>
-        </p:txBody>
-      </p:sp>
-      <p:pic>
-        <p:nvPicPr>
-          <p:cNvPr id="3" name="Picture 2" descr="baud_sweep.png"/>
-          <p:cNvPicPr>
-            <a:picLocks noChangeAspect="1"/>
-          </p:cNvPicPr>
+              <a:t>Formal Channel &amp; Coverage Model</a:t>
+            </a:r>
+          </a:p>
+        </p:txBody>
+      </p:sp>
+      <p:sp>
+        <p:nvSpPr>
+          <p:cNvPr id="3" name="TextBox 2"/>
+          <p:cNvSpPr txBox="1"/>
           <p:nvPr/>
-        </p:nvPicPr>
-        <p:blipFill>
-          <a:blip r:embed="rId3"/>
-          <a:stretch>
-            <a:fillRect/>
-          </a:stretch>
-        </p:blipFill>
+        </p:nvSpPr>
         <p:spPr>
           <a:xfrm>
-            <a:off x="1107469" y="1417320"/>
-            <a:ext cx="9976757" cy="4297680"/>
-          </a:xfrm>
-          <a:prstGeom prst="rect">
-            <a:avLst/>
-          </a:prstGeom>
-        </p:spPr>
-      </p:pic>
-      <p:sp>
-        <p:nvSpPr>
-          <p:cNvPr id="4" name="TextBox 3"/>
-          <p:cNvSpPr txBox="1"/>
-          <p:nvPr/>
-        </p:nvSpPr>
-        <p:spPr>
-          <a:xfrm>
-            <a:off x="502920" y="5806440"/>
-            <a:ext cx="11155680" cy="548640"/>
+            <a:off x="502920" y="1299300"/>
+            <a:ext cx="11155680" cy="300082"/>
           </a:xfrm>
           <a:prstGeom prst="rect">
             <a:avLst/>
@@ -14386,25 +14257,255 @@
           </a:bodyPr>
           <a:lstStyle/>
           <a:p>
-            <a:pPr algn="ctr"/>
-            <a:r>
-              <a:rPr sz="1250" b="1" i="0">
+            <a:r>
+              <a:rPr lang="en-US" sz="1350" i="1" dirty="0">
                 <a:solidFill>
                   <a:srgbClr val="898781"/>
                 </a:solidFill>
                 <a:latin typeface="Calibri"/>
               </a:rPr>
-              <a:t>Higher gain (470kΩ) beats higher bandwidth (100kΩ) at 15cm — SNR margin, not TIA bandwidth, limits close range.</a:t>
+              <a:t>The authorization region is not asserted — it follows from the LED radiation pattern and the receiver FoV.</a:t>
+            </a:r>
+          </a:p>
+        </p:txBody>
+      </p:sp>
+      <p:sp>
+        <p:nvSpPr>
+          <p:cNvPr id="4" name="TextBox 3"/>
+          <p:cNvSpPr txBox="1"/>
+          <p:nvPr/>
+        </p:nvSpPr>
+        <p:spPr>
+          <a:xfrm>
+            <a:off x="685800" y="1600200"/>
+            <a:ext cx="10789920" cy="4755148"/>
+          </a:xfrm>
+          <a:prstGeom prst="rect">
+            <a:avLst/>
+          </a:prstGeom>
+          <a:noFill/>
+        </p:spPr>
+        <p:txBody>
+          <a:bodyPr wrap="square">
+            <a:spAutoFit/>
+          </a:bodyPr>
+          <a:lstStyle/>
+          <a:p>
+            <a:pPr marL="0" indent="0">
+              <a:spcBef>
+                <a:spcPts val="900"/>
+              </a:spcBef>
+              <a:spcAft>
+                <a:spcPts val="500"/>
+              </a:spcAft>
+              <a:buNone/>
+            </a:pPr>
+            <a:r>
+              <a:rPr lang="en-US" sz="1800" b="1" dirty="0">
+                <a:solidFill>
+                  <a:srgbClr val="0B0B0B"/>
+                </a:solidFill>
+                <a:latin typeface="Calibri"/>
+              </a:rPr>
+              <a:t>Lambertian emission order, from the LED half-power semi-angle Φ½</a:t>
+            </a:r>
+          </a:p>
+          <a:p>
+            <a:pPr marL="228600" indent="0" algn="l">
+              <a:spcAft>
+                <a:spcPts val="500"/>
+              </a:spcAft>
+              <a:buNone/>
+            </a:pPr>
+            <a:r>
+              <a:rPr lang="en-US" sz="1900" i="1" dirty="0">
+                <a:solidFill>
+                  <a:srgbClr val="1F3864"/>
+                </a:solidFill>
+                <a:latin typeface="Cambria Math"/>
+              </a:rPr>
+              <a:t>m = − ln 2 / ln( cos Φ½ )        [2]</a:t>
+            </a:r>
+          </a:p>
+          <a:p>
+            <a:pPr marL="0" indent="0">
+              <a:spcBef>
+                <a:spcPts val="900"/>
+              </a:spcBef>
+              <a:spcAft>
+                <a:spcPts val="500"/>
+              </a:spcAft>
+              <a:buNone/>
+            </a:pPr>
+            <a:r>
+              <a:rPr lang="en-US" sz="1800" b="1" dirty="0">
+                <a:solidFill>
+                  <a:srgbClr val="0B0B0B"/>
+                </a:solidFill>
+                <a:latin typeface="Calibri"/>
+              </a:rPr>
+              <a:t>Line-of-sight DC channel gain [2], [3]</a:t>
+            </a:r>
+          </a:p>
+          <a:p>
+            <a:pPr marL="228600" indent="0" algn="l">
+              <a:spcAft>
+                <a:spcPts val="500"/>
+              </a:spcAft>
+              <a:buNone/>
+            </a:pPr>
+            <a:r>
+              <a:rPr lang="en-US" sz="1900" i="1" dirty="0">
+                <a:solidFill>
+                  <a:srgbClr val="1F3864"/>
+                </a:solidFill>
+                <a:latin typeface="Cambria Math"/>
+              </a:rPr>
+              <a:t>H(0) = [ (m+1)·Aᵣ / 2πd² ] · cosᵐ(φ) · Tₛ(ψ) · g(ψ) · cos(ψ),   0 ≤ ψ ≤ Ψᴄ    (0 otherwise)</a:t>
+            </a:r>
+          </a:p>
+          <a:p>
+            <a:pPr marL="228600" indent="0">
+              <a:spcAft>
+                <a:spcPts val="900"/>
+              </a:spcAft>
+              <a:buNone/>
+            </a:pPr>
+            <a:r>
+              <a:rPr lang="en-US" sz="1500" dirty="0">
+                <a:solidFill>
+                  <a:srgbClr val="52514E"/>
+                </a:solidFill>
+                <a:latin typeface="Calibri"/>
+              </a:rPr>
+              <a:t>d = TX–RX distance · φ = irradiance angle · ψ = incidence angle · Aᵣ = detector area · Ψᴄ = receiver FoV half-angle</a:t>
+            </a:r>
+          </a:p>
+          <a:p>
+            <a:pPr marL="0" indent="0">
+              <a:spcBef>
+                <a:spcPts val="900"/>
+              </a:spcBef>
+              <a:spcAft>
+                <a:spcPts val="500"/>
+              </a:spcAft>
+              <a:buNone/>
+            </a:pPr>
+            <a:r>
+              <a:rPr lang="en-US" sz="1800" b="1" dirty="0">
+                <a:solidFill>
+                  <a:srgbClr val="0B0B0B"/>
+                </a:solidFill>
+                <a:latin typeface="Calibri"/>
+              </a:rPr>
+              <a:t>Concentrator gain and received optical power</a:t>
+            </a:r>
+          </a:p>
+          <a:p>
+            <a:pPr marL="228600" indent="0" algn="l">
+              <a:spcAft>
+                <a:spcPts val="500"/>
+              </a:spcAft>
+              <a:buNone/>
+            </a:pPr>
+            <a:r>
+              <a:rPr lang="en-US" sz="1900" i="1" dirty="0">
+                <a:solidFill>
+                  <a:srgbClr val="1F3864"/>
+                </a:solidFill>
+                <a:latin typeface="Cambria Math"/>
+              </a:rPr>
+              <a:t>g(ψ) = n² / sin²(Ψᴄ)          Pᵣ = H(0) · Pₜ        [2]</a:t>
+            </a:r>
+          </a:p>
+          <a:p>
+            <a:pPr marL="0" indent="0">
+              <a:spcBef>
+                <a:spcPts val="900"/>
+              </a:spcBef>
+              <a:spcAft>
+                <a:spcPts val="500"/>
+              </a:spcAft>
+              <a:buNone/>
+            </a:pPr>
+            <a:r>
+              <a:rPr lang="en-US" sz="1800" b="1" dirty="0">
+                <a:solidFill>
+                  <a:srgbClr val="0B0B0B"/>
+                </a:solidFill>
+                <a:latin typeface="Calibri"/>
+              </a:rPr>
+              <a:t>Authorization region — the volume G1 actually protects</a:t>
+            </a:r>
+          </a:p>
+          <a:p>
+            <a:pPr marL="228600" indent="0" algn="l">
+              <a:spcAft>
+                <a:spcPts val="500"/>
+              </a:spcAft>
+              <a:buNone/>
+            </a:pPr>
+            <a:r>
+              <a:rPr lang="en-US" sz="1900" i="1" dirty="0">
+                <a:solidFill>
+                  <a:srgbClr val="1F3864"/>
+                </a:solidFill>
+                <a:latin typeface="Cambria Math"/>
+              </a:rPr>
+              <a:t>Authorized(x) ⇔ Pᵣ(x) ≥ Pₘᵢₙ  ∧  ψ(x) ≤ Ψᴄ        V ≈ (2π/3)·R³·(1 − cos θ)</a:t>
+            </a:r>
+          </a:p>
+          <a:p>
+            <a:pPr marL="228600" indent="0">
+              <a:spcAft>
+                <a:spcPts val="900"/>
+              </a:spcAft>
+              <a:buNone/>
+            </a:pPr>
+            <a:r>
+              <a:rPr lang="en-US" sz="1500" dirty="0">
+                <a:solidFill>
+                  <a:srgbClr val="52514E"/>
+                </a:solidFill>
+                <a:latin typeface="Calibri"/>
+              </a:rPr>
+              <a:t>R and θ are physical constants of the deployment — not yet independently measured on this bench. The model describes the shape of the authorized region; characterizing its exact size is future work.</a:t>
+            </a:r>
+          </a:p>
+          <a:p>
+            <a:pPr marL="0" indent="0">
+              <a:spcBef>
+                <a:spcPts val="1100"/>
+              </a:spcBef>
+              <a:buNone/>
+            </a:pPr>
+            <a:r>
+              <a:rPr lang="en-US" sz="1500" b="1" i="1" dirty="0">
+                <a:solidFill>
+                  <a:srgbClr val="1F3864"/>
+                </a:solidFill>
+                <a:latin typeface="Calibri"/>
+              </a:rPr>
+              <a:t>Provenance: </a:t>
+            </a:r>
+            <a:r>
+              <a:rPr lang="en-US" sz="1500" i="1" dirty="0">
+                <a:solidFill>
+                  <a:srgbClr val="52514E"/>
+                </a:solidFill>
+                <a:latin typeface="Calibri"/>
+              </a:rPr>
+              <a:t>the channel and coverage equations above are standard results from [2], [3]; the volume expression is elementary solid geometry. The authorization predicate and the G3 condition (next slide) are this work’s formulation.</a:t>
             </a:r>
           </a:p>
         </p:txBody>
       </p:sp>
       <p:pic>
         <p:nvPicPr>
-          <p:cNvPr id="5" name="Picture 4" descr="A white background with text&#10;&#10;AI-generated content may be incorrect.">
+          <p:cNvPr id="7" name="Picture 6" descr="A white background with text&#10;&#10;AI-generated content may be incorrect.">
             <a:extLst>
               <a:ext uri="{FF2B5EF4-FFF2-40B4-BE49-F238E27FC236}">
-                <a16:creationId xmlns:a16="http://schemas.microsoft.com/office/drawing/2014/main" id="{261FC07C-93A2-0855-FB99-D948A27FD5A8}"/>
+                <a16:creationId xmlns:a16="http://schemas.microsoft.com/office/drawing/2014/main" id="{E815CBF9-8B4C-C24C-1249-0A42B9A5F6CF}"/>
               </a:ext>
             </a:extLst>
           </p:cNvPr>
@@ -14414,7 +14515,7 @@
           <p:nvPr/>
         </p:nvPicPr>
         <p:blipFill>
-          <a:blip r:embed="rId4"/>
+          <a:blip r:embed="rId3"/>
           <a:stretch>
             <a:fillRect/>
           </a:stretch>
@@ -14431,10 +14532,10 @@
       </p:pic>
       <p:sp>
         <p:nvSpPr>
-          <p:cNvPr id="6" name="Rectangle 5">
+          <p:cNvPr id="8" name="Rectangle 7">
             <a:extLst>
               <a:ext uri="{FF2B5EF4-FFF2-40B4-BE49-F238E27FC236}">
-                <a16:creationId xmlns:a16="http://schemas.microsoft.com/office/drawing/2014/main" id="{A1897D6F-97CB-D526-7BF3-AF37F4721B43}"/>
+                <a16:creationId xmlns:a16="http://schemas.microsoft.com/office/drawing/2014/main" id="{1D78EB68-6E49-6E62-6807-621A767964CE}"/>
               </a:ext>
             </a:extLst>
           </p:cNvPr>
@@ -14491,6 +14592,11 @@
         </p:txBody>
       </p:sp>
     </p:spTree>
+    <p:extLst>
+      <p:ext uri="{BB962C8B-B14F-4D97-AF65-F5344CB8AC3E}">
+        <p14:creationId xmlns:p14="http://schemas.microsoft.com/office/powerpoint/2010/main" val="4254009860"/>
+      </p:ext>
+    </p:extLst>
   </p:cSld>
   <p:clrMapOvr>
     <a:masterClrMapping/>
@@ -14552,7 +14658,7 @@
                 </a:solidFill>
                 <a:latin typeface="Calibri"/>
               </a:rPr>
-              <a:t>Formal Channel &amp; Coverage Model</a:t>
+              <a:t>Proximity Predicate &amp; the G3 Security Condition</a:t>
             </a:r>
           </a:p>
         </p:txBody>
@@ -14586,7 +14692,7 @@
                 </a:solidFill>
                 <a:latin typeface="Calibri"/>
               </a:rPr>
-              <a:t>The authorization region is not asserted — it follows from the LED radiation pattern and the receiver FoV.</a:t>
+              <a:t>What the system actually decides — and the exact inequality on which G3 stands or falls.</a:t>
             </a:r>
           </a:p>
         </p:txBody>
@@ -14600,7 +14706,7 @@
         <p:spPr>
           <a:xfrm>
             <a:off x="685800" y="1600200"/>
-            <a:ext cx="10789920" cy="4755148"/>
+            <a:ext cx="10789920" cy="4821833"/>
           </a:xfrm>
           <a:prstGeom prst="rect">
             <a:avLst/>
@@ -14615,38 +14721,183 @@
           <a:p>
             <a:pPr marL="0" indent="0">
               <a:spcBef>
-                <a:spcPts val="900"/>
+                <a:spcPts val="800"/>
               </a:spcBef>
               <a:spcAft>
-                <a:spcPts val="500"/>
+                <a:spcPts val="400"/>
               </a:spcAft>
               <a:buNone/>
             </a:pPr>
             <a:r>
-              <a:rPr lang="en-US" sz="1800" b="1" dirty="0">
+              <a:rPr lang="en-US" sz="1750" b="1" dirty="0">
                 <a:solidFill>
                   <a:srgbClr val="0B0B0B"/>
                 </a:solidFill>
                 <a:latin typeface="Calibri"/>
               </a:rPr>
-              <a:t>Lambertian emission order, from the LED half-power semi-angle Φ½</a:t>
-            </a:r>
-          </a:p>
-          <a:p>
-            <a:pPr marL="228600" indent="0" algn="l">
+              <a:t>Classical distance bound from round-trip time [4], [5]</a:t>
+            </a:r>
+          </a:p>
+          <a:p>
+            <a:pPr marL="228600" indent="0">
               <a:spcAft>
-                <a:spcPts val="500"/>
+                <a:spcPts val="300"/>
               </a:spcAft>
               <a:buNone/>
             </a:pPr>
             <a:r>
-              <a:rPr lang="en-US" sz="1900" i="1" dirty="0">
+              <a:rPr lang="en-US" sz="1800" i="1" dirty="0">
                 <a:solidFill>
                   <a:srgbClr val="1F3864"/>
                 </a:solidFill>
                 <a:latin typeface="Cambria Math"/>
               </a:rPr>
-              <a:t>m = − ln 2 / ln( cos Φ½ )        [2]</a:t>
+              <a:t>d ≤ c · ( t_RTT − t_proc ) / 2</a:t>
+            </a:r>
+          </a:p>
+          <a:p>
+            <a:pPr marL="228600" indent="0">
+              <a:spcAft>
+                <a:spcPts val="600"/>
+              </a:spcAft>
+              <a:buNone/>
+            </a:pPr>
+            <a:r>
+              <a:rPr lang="en-US" sz="1500" dirty="0">
+                <a:solidFill>
+                  <a:srgbClr val="52514E"/>
+                </a:solidFill>
+                <a:latin typeface="Calibri"/>
+              </a:rPr>
+              <a:t>This bounds distance only when timing resolution is small relative to c. At Pico-class resolution it is not a distance bound — it is a latency bound. Stated here so the distinction is explicit.</a:t>
+            </a:r>
+          </a:p>
+          <a:p>
+            <a:pPr marL="0" indent="0">
+              <a:spcBef>
+                <a:spcPts val="800"/>
+              </a:spcBef>
+              <a:spcAft>
+                <a:spcPts val="400"/>
+              </a:spcAft>
+              <a:buNone/>
+            </a:pPr>
+            <a:r>
+              <a:rPr lang="en-US" sz="1750" b="1" dirty="0">
+                <a:solidFill>
+                  <a:srgbClr val="0B0B0B"/>
+                </a:solidFill>
+                <a:latin typeface="Calibri"/>
+              </a:rPr>
+              <a:t>Acceptance predicate as implemented</a:t>
+            </a:r>
+          </a:p>
+          <a:p>
+            <a:pPr marL="228600" indent="0">
+              <a:spcAft>
+                <a:spcPts val="300"/>
+              </a:spcAft>
+              <a:buNone/>
+            </a:pPr>
+            <a:r>
+              <a:rPr lang="en-US" sz="1800" i="1" dirty="0">
+                <a:solidFill>
+                  <a:srgbClr val="1F3864"/>
+                </a:solidFill>
+                <a:latin typeface="Cambria Math"/>
+              </a:rPr>
+              <a:t>Accept ⇔ MACₖ(B) valid  ∧  | t_now − t_B | ≤ W  ∧  N ∉ Seen  ∧  RTT ≤ Δ</a:t>
+            </a:r>
+          </a:p>
+          <a:p>
+            <a:pPr marL="0" indent="0">
+              <a:spcBef>
+                <a:spcPts val="800"/>
+              </a:spcBef>
+              <a:spcAft>
+                <a:spcPts val="400"/>
+              </a:spcAft>
+              <a:buNone/>
+            </a:pPr>
+            <a:r>
+              <a:rPr lang="en-US" sz="1750" b="1" dirty="0">
+                <a:solidFill>
+                  <a:srgbClr val="0B0B0B"/>
+                </a:solidFill>
+                <a:latin typeface="Calibri"/>
+              </a:rPr>
+              <a:t>The G3 condition</a:t>
+            </a:r>
+          </a:p>
+          <a:p>
+            <a:pPr marL="228600" indent="0">
+              <a:spcAft>
+                <a:spcPts val="300"/>
+              </a:spcAft>
+              <a:buNone/>
+            </a:pPr>
+            <a:r>
+              <a:rPr lang="en-US" sz="1800" i="1" dirty="0">
+                <a:solidFill>
+                  <a:srgbClr val="1F3864"/>
+                </a:solidFill>
+                <a:latin typeface="Cambria Math"/>
+              </a:rPr>
+              <a:t>G3 holds ⇔ Δ &lt; L_relay      where L_relay = min feasible relay latency</a:t>
+            </a:r>
+          </a:p>
+          <a:p>
+            <a:pPr marL="228600" indent="0">
+              <a:spcAft>
+                <a:spcPts val="600"/>
+              </a:spcAft>
+              <a:buNone/>
+            </a:pPr>
+            <a:r>
+              <a:rPr lang="en-US" sz="1500" dirty="0">
+                <a:solidFill>
+                  <a:srgbClr val="52514E"/>
+                </a:solidFill>
+                <a:latin typeface="Calibri"/>
+              </a:rPr>
+              <a:t>Decode-and-forward relays report L_relay ≈ 200–500 ms [6]; any Δ below that is rejected. Amplify-and-forward relays drive L_relay toward zero, so no achievable Δ detects them [7] — the optical geometry of the previous slide, not the timing bound, is what raises their cost.</a:t>
+            </a:r>
+          </a:p>
+          <a:p>
+            <a:pPr marL="0" indent="0">
+              <a:spcBef>
+                <a:spcPts val="800"/>
+              </a:spcBef>
+              <a:spcAft>
+                <a:spcPts val="400"/>
+              </a:spcAft>
+              <a:buNone/>
+            </a:pPr>
+            <a:r>
+              <a:rPr lang="en-US" sz="1750" b="1" dirty="0">
+                <a:solidFill>
+                  <a:srgbClr val="0B0B0B"/>
+                </a:solidFill>
+                <a:latin typeface="Calibri"/>
+              </a:rPr>
+              <a:t>Why the two defenses are a pair, not a redundancy</a:t>
+            </a:r>
+          </a:p>
+          <a:p>
+            <a:pPr marL="228600" indent="0">
+              <a:spcAft>
+                <a:spcPts val="600"/>
+              </a:spcAft>
+              <a:buNone/>
+            </a:pPr>
+            <a:r>
+              <a:rPr lang="en-US" sz="1500" dirty="0">
+                <a:solidFill>
+                  <a:srgbClr val="52514E"/>
+                </a:solidFill>
+                <a:latin typeface="Calibri"/>
+              </a:rPr>
+              <a:t>Timing (Δ) closes the digital-relay path; the bounded cone V closes the physical-reach path. Neither is sufficient alone.</a:t>
             </a:r>
           </a:p>
           <a:p>
@@ -14654,170 +14905,25 @@
               <a:spcBef>
                 <a:spcPts val="900"/>
               </a:spcBef>
-              <a:spcAft>
-                <a:spcPts val="500"/>
-              </a:spcAft>
               <a:buNone/>
             </a:pPr>
             <a:r>
-              <a:rPr lang="en-US" sz="1800" b="1" dirty="0">
-                <a:solidFill>
-                  <a:srgbClr val="0B0B0B"/>
+              <a:rPr lang="en-US" sz="1500" b="1" i="1" dirty="0">
+                <a:solidFill>
+                  <a:srgbClr val="1F3864"/>
                 </a:solidFill>
                 <a:latin typeface="Calibri"/>
               </a:rPr>
-              <a:t>Line-of-sight DC channel gain [2], [3]</a:t>
-            </a:r>
-          </a:p>
-          <a:p>
-            <a:pPr marL="228600" indent="0" algn="l">
-              <a:spcAft>
-                <a:spcPts val="500"/>
-              </a:spcAft>
-              <a:buNone/>
-            </a:pPr>
-            <a:r>
-              <a:rPr lang="en-US" sz="1900" i="1" dirty="0">
-                <a:solidFill>
-                  <a:srgbClr val="1F3864"/>
-                </a:solidFill>
-                <a:latin typeface="Cambria Math"/>
-              </a:rPr>
-              <a:t>H(0) = [ (m+1)·Aᵣ / 2πd² ] · cosᵐ(φ) · Tₛ(ψ) · g(ψ) · cos(ψ),   0 ≤ ψ ≤ Ψᴄ    (0 otherwise)</a:t>
-            </a:r>
-          </a:p>
-          <a:p>
-            <a:pPr marL="228600" indent="0">
-              <a:spcAft>
-                <a:spcPts val="900"/>
-              </a:spcAft>
-              <a:buNone/>
-            </a:pPr>
-            <a:r>
-              <a:rPr lang="en-US" sz="1500" dirty="0">
+              <a:t>Provenance: </a:t>
+            </a:r>
+            <a:r>
+              <a:rPr lang="en-US" sz="1500" i="1" dirty="0">
                 <a:solidFill>
                   <a:srgbClr val="52514E"/>
                 </a:solidFill>
                 <a:latin typeface="Calibri"/>
               </a:rPr>
-              <a:t>d = TX–RX distance · φ = irradiance angle · ψ = incidence angle · Aᵣ = detector area · Ψᴄ = receiver FoV half-angle</a:t>
-            </a:r>
-          </a:p>
-          <a:p>
-            <a:pPr marL="0" indent="0">
-              <a:spcBef>
-                <a:spcPts val="900"/>
-              </a:spcBef>
-              <a:spcAft>
-                <a:spcPts val="500"/>
-              </a:spcAft>
-              <a:buNone/>
-            </a:pPr>
-            <a:r>
-              <a:rPr lang="en-US" sz="1800" b="1" dirty="0">
-                <a:solidFill>
-                  <a:srgbClr val="0B0B0B"/>
-                </a:solidFill>
-                <a:latin typeface="Calibri"/>
-              </a:rPr>
-              <a:t>Concentrator gain and received optical power</a:t>
-            </a:r>
-          </a:p>
-          <a:p>
-            <a:pPr marL="228600" indent="0" algn="l">
-              <a:spcAft>
-                <a:spcPts val="500"/>
-              </a:spcAft>
-              <a:buNone/>
-            </a:pPr>
-            <a:r>
-              <a:rPr lang="en-US" sz="1900" i="1" dirty="0">
-                <a:solidFill>
-                  <a:srgbClr val="1F3864"/>
-                </a:solidFill>
-                <a:latin typeface="Cambria Math"/>
-              </a:rPr>
-              <a:t>g(ψ) = n² / sin²(Ψᴄ)          Pᵣ = H(0) · Pₜ        [2]</a:t>
-            </a:r>
-          </a:p>
-          <a:p>
-            <a:pPr marL="0" indent="0">
-              <a:spcBef>
-                <a:spcPts val="900"/>
-              </a:spcBef>
-              <a:spcAft>
-                <a:spcPts val="500"/>
-              </a:spcAft>
-              <a:buNone/>
-            </a:pPr>
-            <a:r>
-              <a:rPr lang="en-US" sz="1800" b="1" dirty="0">
-                <a:solidFill>
-                  <a:srgbClr val="0B0B0B"/>
-                </a:solidFill>
-                <a:latin typeface="Calibri"/>
-              </a:rPr>
-              <a:t>Authorization region — the volume G1 actually protects</a:t>
-            </a:r>
-          </a:p>
-          <a:p>
-            <a:pPr marL="228600" indent="0" algn="l">
-              <a:spcAft>
-                <a:spcPts val="500"/>
-              </a:spcAft>
-              <a:buNone/>
-            </a:pPr>
-            <a:r>
-              <a:rPr lang="en-US" sz="1900" i="1" dirty="0">
-                <a:solidFill>
-                  <a:srgbClr val="1F3864"/>
-                </a:solidFill>
-                <a:latin typeface="Cambria Math"/>
-              </a:rPr>
-              <a:t>Authorized(x) ⇔ Pᵣ(x) ≥ Pₘᵢₙ  ∧  ψ(x) ≤ Ψᴄ        V ≈ (2π/3)·R³·(1 − cos θ)</a:t>
-            </a:r>
-          </a:p>
-          <a:p>
-            <a:pPr marL="228600" indent="0">
-              <a:spcAft>
-                <a:spcPts val="900"/>
-              </a:spcAft>
-              <a:buNone/>
-            </a:pPr>
-            <a:r>
-              <a:rPr lang="en-US" sz="1500" dirty="0">
-                <a:solidFill>
-                  <a:srgbClr val="52514E"/>
-                </a:solidFill>
-                <a:latin typeface="Calibri"/>
-              </a:rPr>
-              <a:t>R and θ are physical constants of the deployment — not yet independently measured on this bench. The model describes the shape of the authorized region; characterizing its exact size is future work.</a:t>
-            </a:r>
-          </a:p>
-          <a:p>
-            <a:pPr marL="0" indent="0">
-              <a:spcBef>
-                <a:spcPts val="1100"/>
-              </a:spcBef>
-              <a:buNone/>
-            </a:pPr>
-            <a:r>
-              <a:rPr lang="en-US" sz="1500" b="1" i="1" dirty="0">
-                <a:solidFill>
-                  <a:srgbClr val="1F3864"/>
-                </a:solidFill>
-                <a:latin typeface="Calibri"/>
-              </a:rPr>
-              <a:t>Provenance: </a:t>
-            </a:r>
-            <a:r>
-              <a:rPr lang="en-US" sz="1500" i="1" dirty="0">
-                <a:solidFill>
-                  <a:srgbClr val="52514E"/>
-                </a:solidFill>
-                <a:latin typeface="Calibri"/>
-              </a:rPr>
-              <a:t>the channel and coverage equations above are standard results from [2], [3]; the volume expression is elementary solid geometry. The authorization predicate and the G3 condition (next slide) are this work’s formulation.</a:t>
+              <a:t>the RTT distance bound is due to [4], [5]; relay-latency figures are from [6], [7]. The acceptance predicate and the G3 condition are this work’s formulation.</a:t>
             </a:r>
           </a:p>
         </p:txBody>
@@ -14916,7 +15022,7 @@
     </p:spTree>
     <p:extLst>
       <p:ext uri="{BB962C8B-B14F-4D97-AF65-F5344CB8AC3E}">
-        <p14:creationId xmlns:p14="http://schemas.microsoft.com/office/powerpoint/2010/main" val="4254009860"/>
+        <p14:creationId xmlns:p14="http://schemas.microsoft.com/office/powerpoint/2010/main" val="1851031038"/>
       </p:ext>
     </p:extLst>
   </p:cSld>
@@ -14959,8 +15065,8 @@
         </p:nvSpPr>
         <p:spPr>
           <a:xfrm>
-            <a:off x="533400" y="777240"/>
-            <a:ext cx="11155680" cy="538609"/>
+            <a:off x="502920" y="777240"/>
+            <a:ext cx="11155680" cy="822960"/>
           </a:xfrm>
           <a:prstGeom prst="rect">
             <a:avLst/>
@@ -14974,13 +15080,13 @@
           <a:lstStyle/>
           <a:p>
             <a:r>
-              <a:rPr lang="en-US" sz="2900" b="1" dirty="0">
+              <a:rPr sz="2900" b="1">
                 <a:solidFill>
                   <a:srgbClr val="0B0B0B"/>
                 </a:solidFill>
                 <a:latin typeface="Calibri"/>
               </a:rPr>
-              <a:t>Proximity Predicate &amp; the G3 Security Condition</a:t>
+              <a:t>G3 — A Named Limitation, Not a Discovered Gap</a:t>
             </a:r>
           </a:p>
         </p:txBody>
@@ -14993,8 +15099,8 @@
         </p:nvSpPr>
         <p:spPr>
           <a:xfrm>
-            <a:off x="502920" y="1299300"/>
-            <a:ext cx="11155680" cy="300082"/>
+            <a:off x="685800" y="1600200"/>
+            <a:ext cx="10789920" cy="4572000"/>
           </a:xfrm>
           <a:prstGeom prst="rect">
             <a:avLst/>
@@ -15007,255 +15113,141 @@
           </a:bodyPr>
           <a:lstStyle/>
           <a:p>
-            <a:r>
-              <a:rPr lang="en-US" sz="1350" i="1" dirty="0">
-                <a:solidFill>
-                  <a:srgbClr val="898781"/>
+            <a:pPr>
+              <a:spcAft>
+                <a:spcPts val="1100"/>
+              </a:spcAft>
+            </a:pPr>
+            <a:r>
+              <a:rPr sz="1700">
+                <a:solidFill>
+                  <a:srgbClr val="0B0B0B"/>
                 </a:solidFill>
                 <a:latin typeface="Calibri"/>
               </a:rPr>
-              <a:t>What the system actually decides — and the exact inequality on which G3 stands or falls.</a:t>
-            </a:r>
-          </a:p>
-        </p:txBody>
-      </p:sp>
-      <p:sp>
-        <p:nvSpPr>
-          <p:cNvPr id="4" name="TextBox 3"/>
-          <p:cNvSpPr txBox="1"/>
-          <p:nvPr/>
-        </p:nvSpPr>
-        <p:spPr>
-          <a:xfrm>
-            <a:off x="685800" y="1600200"/>
-            <a:ext cx="10789920" cy="4821833"/>
-          </a:xfrm>
-          <a:prstGeom prst="rect">
-            <a:avLst/>
-          </a:prstGeom>
-          <a:noFill/>
-        </p:spPr>
-        <p:txBody>
-          <a:bodyPr wrap="square">
-            <a:spAutoFit/>
-          </a:bodyPr>
-          <a:lstStyle/>
-          <a:p>
-            <a:pPr marL="0" indent="0">
-              <a:spcBef>
-                <a:spcPts val="800"/>
-              </a:spcBef>
+              <a:t>●   G1 bounds how long a captured, later-resent frame stays useful. G2 rejects a byte-identical resend outright.</a:t>
+            </a:r>
+          </a:p>
+          <a:p>
+            <a:pPr>
               <a:spcAft>
-                <a:spcPts val="400"/>
+                <a:spcPts val="1100"/>
               </a:spcAft>
-              <a:buNone/>
             </a:pPr>
             <a:r>
-              <a:rPr lang="en-US" sz="1750" b="1" dirty="0">
+              <a:rPr sz="1700">
                 <a:solidFill>
                   <a:srgbClr val="0B0B0B"/>
                 </a:solidFill>
                 <a:latin typeface="Calibri"/>
               </a:rPr>
-              <a:t>Classical distance bound from round-trip time [4], [5]</a:t>
-            </a:r>
-          </a:p>
-          <a:p>
-            <a:pPr marL="228600" indent="0">
+              <a:t>●   Neither mechanism examines WHEN a frame arrived — only whether its nonce is fresh and previously unseen</a:t>
+            </a:r>
+          </a:p>
+          <a:p>
+            <a:pPr>
               <a:spcAft>
-                <a:spcPts val="300"/>
+                <a:spcPts val="1100"/>
               </a:spcAft>
-              <a:buNone/>
             </a:pPr>
             <a:r>
-              <a:rPr lang="en-US" sz="1800" i="1" dirty="0">
-                <a:solidFill>
-                  <a:srgbClr val="1F3864"/>
-                </a:solidFill>
-                <a:latin typeface="Cambria Math"/>
-              </a:rPr>
-              <a:t>d ≤ c · ( t_RTT − t_proc ) / 2</a:t>
-            </a:r>
-          </a:p>
-          <a:p>
-            <a:pPr marL="228600" indent="0">
+              <a:rPr sz="1700">
+                <a:solidFill>
+                  <a:srgbClr val="0B0B0B"/>
+                </a:solidFill>
+                <a:latin typeface="Calibri"/>
+              </a:rPr>
+              <a:t>●   A live relay forwarding genuinely fresh frames in real time passes every check the receiver performs:</a:t>
+            </a:r>
+          </a:p>
+          <a:p>
+            <a:pPr lvl="1">
               <a:spcAft>
-                <a:spcPts val="600"/>
+                <a:spcPts val="700"/>
               </a:spcAft>
-              <a:buNone/>
             </a:pPr>
             <a:r>
-              <a:rPr lang="en-US" sz="1500" dirty="0">
+              <a:rPr sz="1450">
                 <a:solidFill>
                   <a:srgbClr val="52514E"/>
                 </a:solidFill>
                 <a:latin typeface="Calibri"/>
               </a:rPr>
-              <a:t>This bounds distance only when timing resolution is small relative to c. At Pico-class resolution it is not a distance bound — it is a latency bound. Stated here so the distinction is explicit.</a:t>
-            </a:r>
-          </a:p>
-          <a:p>
-            <a:pPr marL="0" indent="0">
-              <a:spcBef>
-                <a:spcPts val="800"/>
-              </a:spcBef>
+              <a:t>‒   Nonce never seen before → G2 passes</a:t>
+            </a:r>
+          </a:p>
+          <a:p>
+            <a:pPr lvl="1">
               <a:spcAft>
-                <a:spcPts val="400"/>
+                <a:spcPts val="700"/>
               </a:spcAft>
-              <a:buNone/>
             </a:pPr>
             <a:r>
-              <a:rPr lang="en-US" sz="1750" b="1" dirty="0">
+              <a:rPr sz="1450">
+                <a:solidFill>
+                  <a:srgbClr val="52514E"/>
+                </a:solidFill>
+                <a:latin typeface="Calibri"/>
+              </a:rPr>
+              <a:t>‒   GCM tag valid, ciphertext untouched → confidentiality/integrity passes</a:t>
+            </a:r>
+          </a:p>
+          <a:p>
+            <a:pPr lvl="1">
+              <a:spcAft>
+                <a:spcPts val="700"/>
+              </a:spcAft>
+            </a:pPr>
+            <a:r>
+              <a:rPr sz="1450">
+                <a:solidFill>
+                  <a:srgbClr val="52514E"/>
+                </a:solidFill>
+                <a:latin typeface="Calibri"/>
+              </a:rPr>
+              <a:t>‒   t_last continuously refreshed by relayed-but-fresh frames → G1 passes</a:t>
+            </a:r>
+          </a:p>
+          <a:p>
+            <a:pPr>
+              <a:spcAft>
+                <a:spcPts val="1100"/>
+              </a:spcAft>
+            </a:pPr>
+            <a:r>
+              <a:rPr sz="1700">
                 <a:solidFill>
                   <a:srgbClr val="0B0B0B"/>
                 </a:solidFill>
                 <a:latin typeface="Calibri"/>
               </a:rPr>
-              <a:t>Acceptance predicate as implemented</a:t>
-            </a:r>
-          </a:p>
-          <a:p>
-            <a:pPr marL="228600" indent="0">
+              <a:t>●   Verified directly in the receiver implementation: the LiFi data-frame path checks only CRC and byte-exact nonce identity — no timestamp, no round-trip bound</a:t>
+            </a:r>
+          </a:p>
+          <a:p>
+            <a:pPr>
               <a:spcAft>
-                <a:spcPts val="300"/>
+                <a:spcPts val="1100"/>
               </a:spcAft>
-              <a:buNone/>
             </a:pPr>
             <a:r>
-              <a:rPr lang="en-US" sz="1800" i="1" dirty="0">
-                <a:solidFill>
-                  <a:srgbClr val="1F3864"/>
-                </a:solidFill>
-                <a:latin typeface="Cambria Math"/>
-              </a:rPr>
-              <a:t>Accept ⇔ MACₖ(B) valid  ∧  | t_now − t_B | ≤ W  ∧  N ∉ Seen  ∧  RTT ≤ Δ</a:t>
-            </a:r>
-          </a:p>
-          <a:p>
-            <a:pPr marL="0" indent="0">
-              <a:spcBef>
-                <a:spcPts val="800"/>
-              </a:spcBef>
-              <a:spcAft>
-                <a:spcPts val="400"/>
-              </a:spcAft>
-              <a:buNone/>
-            </a:pPr>
-            <a:r>
-              <a:rPr lang="en-US" sz="1750" b="1" dirty="0">
+              <a:rPr sz="1700">
                 <a:solidFill>
                   <a:srgbClr val="0B0B0B"/>
                 </a:solidFill>
                 <a:latin typeface="Calibri"/>
               </a:rPr>
-              <a:t>The G3 condition</a:t>
-            </a:r>
-          </a:p>
-          <a:p>
-            <a:pPr marL="228600" indent="0">
-              <a:spcAft>
-                <a:spcPts val="300"/>
-              </a:spcAft>
-              <a:buNone/>
-            </a:pPr>
-            <a:r>
-              <a:rPr lang="en-US" sz="1800" i="1" dirty="0">
-                <a:solidFill>
-                  <a:srgbClr val="1F3864"/>
-                </a:solidFill>
-                <a:latin typeface="Cambria Math"/>
-              </a:rPr>
-              <a:t>G3 holds ⇔ Δ &lt; L_relay      where L_relay = min feasible relay latency</a:t>
-            </a:r>
-          </a:p>
-          <a:p>
-            <a:pPr marL="228600" indent="0">
-              <a:spcAft>
-                <a:spcPts val="600"/>
-              </a:spcAft>
-              <a:buNone/>
-            </a:pPr>
-            <a:r>
-              <a:rPr lang="en-US" sz="1500" dirty="0">
-                <a:solidFill>
-                  <a:srgbClr val="52514E"/>
-                </a:solidFill>
-                <a:latin typeface="Calibri"/>
-              </a:rPr>
-              <a:t>Decode-and-forward relays report L_relay ≈ 200–500 ms [6]; any Δ below that is rejected. Amplify-and-forward relays drive L_relay toward zero, so no achievable Δ detects them [7] — the optical geometry of the previous slide, not the timing bound, is what raises their cost.</a:t>
-            </a:r>
-          </a:p>
-          <a:p>
-            <a:pPr marL="0" indent="0">
-              <a:spcBef>
-                <a:spcPts val="800"/>
-              </a:spcBef>
-              <a:spcAft>
-                <a:spcPts val="400"/>
-              </a:spcAft>
-              <a:buNone/>
-            </a:pPr>
-            <a:r>
-              <a:rPr lang="en-US" sz="1750" b="1" dirty="0">
-                <a:solidFill>
-                  <a:srgbClr val="0B0B0B"/>
-                </a:solidFill>
-                <a:latin typeface="Calibri"/>
-              </a:rPr>
-              <a:t>Why the two defenses are a pair, not a redundancy</a:t>
-            </a:r>
-          </a:p>
-          <a:p>
-            <a:pPr marL="228600" indent="0">
-              <a:spcAft>
-                <a:spcPts val="600"/>
-              </a:spcAft>
-              <a:buNone/>
-            </a:pPr>
-            <a:r>
-              <a:rPr lang="en-US" sz="1500" dirty="0">
-                <a:solidFill>
-                  <a:srgbClr val="52514E"/>
-                </a:solidFill>
-                <a:latin typeface="Calibri"/>
-              </a:rPr>
-              <a:t>Timing (Δ) closes the digital-relay path; the bounded cone V closes the physical-reach path. Neither is sufficient alone.</a:t>
-            </a:r>
-          </a:p>
-          <a:p>
-            <a:pPr marL="0" indent="0">
-              <a:spcBef>
-                <a:spcPts val="900"/>
-              </a:spcBef>
-              <a:buNone/>
-            </a:pPr>
-            <a:r>
-              <a:rPr lang="en-US" sz="1500" b="1" i="1" dirty="0">
-                <a:solidFill>
-                  <a:srgbClr val="1F3864"/>
-                </a:solidFill>
-                <a:latin typeface="Calibri"/>
-              </a:rPr>
-              <a:t>Provenance: </a:t>
-            </a:r>
-            <a:r>
-              <a:rPr lang="en-US" sz="1500" i="1" dirty="0">
-                <a:solidFill>
-                  <a:srgbClr val="52514E"/>
-                </a:solidFill>
-                <a:latin typeface="Calibri"/>
-              </a:rPr>
-              <a:t>the RTT distance bound is due to [4], [5]; relay-latency figures are from [6], [7]. The acceptance predicate and the G3 condition are this work’s formulation.</a:t>
+              <a:t>●   What closing this gap requires: a Brands–Chaum-style distance-bounding challenge-response, binding authorization to measured round-trip time</a:t>
             </a:r>
           </a:p>
         </p:txBody>
       </p:sp>
       <p:pic>
         <p:nvPicPr>
-          <p:cNvPr id="7" name="Picture 6" descr="A white background with text&#10;&#10;AI-generated content may be incorrect.">
+          <p:cNvPr id="4" name="Picture 3" descr="A white background with text&#10;&#10;AI-generated content may be incorrect.">
             <a:extLst>
               <a:ext uri="{FF2B5EF4-FFF2-40B4-BE49-F238E27FC236}">
-                <a16:creationId xmlns:a16="http://schemas.microsoft.com/office/drawing/2014/main" id="{E815CBF9-8B4C-C24C-1249-0A42B9A5F6CF}"/>
+                <a16:creationId xmlns:a16="http://schemas.microsoft.com/office/drawing/2014/main" id="{0BB6CE34-40C2-0B05-8971-B7281C4F44AB}"/>
               </a:ext>
             </a:extLst>
           </p:cNvPr>
@@ -15282,10 +15274,10 @@
       </p:pic>
       <p:sp>
         <p:nvSpPr>
-          <p:cNvPr id="8" name="Rectangle 7">
+          <p:cNvPr id="5" name="Rectangle 4">
             <a:extLst>
               <a:ext uri="{FF2B5EF4-FFF2-40B4-BE49-F238E27FC236}">
-                <a16:creationId xmlns:a16="http://schemas.microsoft.com/office/drawing/2014/main" id="{1D78EB68-6E49-6E62-6807-621A767964CE}"/>
+                <a16:creationId xmlns:a16="http://schemas.microsoft.com/office/drawing/2014/main" id="{B3523F97-9585-DF87-5CEF-7FE7F49B935D}"/>
               </a:ext>
             </a:extLst>
           </p:cNvPr>
@@ -15342,11 +15334,6 @@
         </p:txBody>
       </p:sp>
     </p:spTree>
-    <p:extLst>
-      <p:ext uri="{BB962C8B-B14F-4D97-AF65-F5344CB8AC3E}">
-        <p14:creationId xmlns:p14="http://schemas.microsoft.com/office/powerpoint/2010/main" val="1851031038"/>
-      </p:ext>
-    </p:extLst>
   </p:cSld>
   <p:clrMapOvr>
     <a:masterClrMapping/>
@@ -15355,315 +15342,6 @@
 </file>
 
 <file path=ppt/slides/slide24.xml><?xml version="1.0" encoding="utf-8"?>
-<p:sld xmlns:a="http://schemas.openxmlformats.org/drawingml/2006/main" xmlns:r="http://schemas.openxmlformats.org/officeDocument/2006/relationships" xmlns:p="http://schemas.openxmlformats.org/presentationml/2006/main">
-  <p:cSld>
-    <p:bg>
-      <p:bgPr>
-        <a:solidFill>
-          <a:srgbClr val="FCFCFB"/>
-        </a:solidFill>
-        <a:effectLst/>
-      </p:bgPr>
-    </p:bg>
-    <p:spTree>
-      <p:nvGrpSpPr>
-        <p:cNvPr id="1" name=""/>
-        <p:cNvGrpSpPr/>
-        <p:nvPr/>
-      </p:nvGrpSpPr>
-      <p:grpSpPr>
-        <a:xfrm>
-          <a:off x="0" y="0"/>
-          <a:ext cx="0" cy="0"/>
-          <a:chOff x="0" y="0"/>
-          <a:chExt cx="0" cy="0"/>
-        </a:xfrm>
-      </p:grpSpPr>
-      <p:sp>
-        <p:nvSpPr>
-          <p:cNvPr id="2" name="TextBox 1"/>
-          <p:cNvSpPr txBox="1"/>
-          <p:nvPr/>
-        </p:nvSpPr>
-        <p:spPr>
-          <a:xfrm>
-            <a:off x="502920" y="777240"/>
-            <a:ext cx="11155680" cy="822960"/>
-          </a:xfrm>
-          <a:prstGeom prst="rect">
-            <a:avLst/>
-          </a:prstGeom>
-          <a:noFill/>
-        </p:spPr>
-        <p:txBody>
-          <a:bodyPr wrap="square">
-            <a:spAutoFit/>
-          </a:bodyPr>
-          <a:lstStyle/>
-          <a:p>
-            <a:r>
-              <a:rPr sz="2900" b="1">
-                <a:solidFill>
-                  <a:srgbClr val="0B0B0B"/>
-                </a:solidFill>
-                <a:latin typeface="Calibri"/>
-              </a:rPr>
-              <a:t>G3 — A Named Limitation, Not a Discovered Gap</a:t>
-            </a:r>
-          </a:p>
-        </p:txBody>
-      </p:sp>
-      <p:sp>
-        <p:nvSpPr>
-          <p:cNvPr id="3" name="TextBox 2"/>
-          <p:cNvSpPr txBox="1"/>
-          <p:nvPr/>
-        </p:nvSpPr>
-        <p:spPr>
-          <a:xfrm>
-            <a:off x="685800" y="1600200"/>
-            <a:ext cx="10789920" cy="4572000"/>
-          </a:xfrm>
-          <a:prstGeom prst="rect">
-            <a:avLst/>
-          </a:prstGeom>
-          <a:noFill/>
-        </p:spPr>
-        <p:txBody>
-          <a:bodyPr wrap="square">
-            <a:spAutoFit/>
-          </a:bodyPr>
-          <a:lstStyle/>
-          <a:p>
-            <a:pPr>
-              <a:spcAft>
-                <a:spcPts val="1100"/>
-              </a:spcAft>
-            </a:pPr>
-            <a:r>
-              <a:rPr sz="1700">
-                <a:solidFill>
-                  <a:srgbClr val="0B0B0B"/>
-                </a:solidFill>
-                <a:latin typeface="Calibri"/>
-              </a:rPr>
-              <a:t>●   G1 bounds how long a captured, later-resent frame stays useful. G2 rejects a byte-identical resend outright.</a:t>
-            </a:r>
-          </a:p>
-          <a:p>
-            <a:pPr>
-              <a:spcAft>
-                <a:spcPts val="1100"/>
-              </a:spcAft>
-            </a:pPr>
-            <a:r>
-              <a:rPr sz="1700">
-                <a:solidFill>
-                  <a:srgbClr val="0B0B0B"/>
-                </a:solidFill>
-                <a:latin typeface="Calibri"/>
-              </a:rPr>
-              <a:t>●   Neither mechanism examines WHEN a frame arrived — only whether its nonce is fresh and previously unseen</a:t>
-            </a:r>
-          </a:p>
-          <a:p>
-            <a:pPr>
-              <a:spcAft>
-                <a:spcPts val="1100"/>
-              </a:spcAft>
-            </a:pPr>
-            <a:r>
-              <a:rPr sz="1700">
-                <a:solidFill>
-                  <a:srgbClr val="0B0B0B"/>
-                </a:solidFill>
-                <a:latin typeface="Calibri"/>
-              </a:rPr>
-              <a:t>●   A live relay forwarding genuinely fresh frames in real time passes every check the receiver performs:</a:t>
-            </a:r>
-          </a:p>
-          <a:p>
-            <a:pPr lvl="1">
-              <a:spcAft>
-                <a:spcPts val="700"/>
-              </a:spcAft>
-            </a:pPr>
-            <a:r>
-              <a:rPr sz="1450">
-                <a:solidFill>
-                  <a:srgbClr val="52514E"/>
-                </a:solidFill>
-                <a:latin typeface="Calibri"/>
-              </a:rPr>
-              <a:t>‒   Nonce never seen before → G2 passes</a:t>
-            </a:r>
-          </a:p>
-          <a:p>
-            <a:pPr lvl="1">
-              <a:spcAft>
-                <a:spcPts val="700"/>
-              </a:spcAft>
-            </a:pPr>
-            <a:r>
-              <a:rPr sz="1450">
-                <a:solidFill>
-                  <a:srgbClr val="52514E"/>
-                </a:solidFill>
-                <a:latin typeface="Calibri"/>
-              </a:rPr>
-              <a:t>‒   GCM tag valid, ciphertext untouched → confidentiality/integrity passes</a:t>
-            </a:r>
-          </a:p>
-          <a:p>
-            <a:pPr lvl="1">
-              <a:spcAft>
-                <a:spcPts val="700"/>
-              </a:spcAft>
-            </a:pPr>
-            <a:r>
-              <a:rPr sz="1450">
-                <a:solidFill>
-                  <a:srgbClr val="52514E"/>
-                </a:solidFill>
-                <a:latin typeface="Calibri"/>
-              </a:rPr>
-              <a:t>‒   t_last continuously refreshed by relayed-but-fresh frames → G1 passes</a:t>
-            </a:r>
-          </a:p>
-          <a:p>
-            <a:pPr>
-              <a:spcAft>
-                <a:spcPts val="1100"/>
-              </a:spcAft>
-            </a:pPr>
-            <a:r>
-              <a:rPr sz="1700">
-                <a:solidFill>
-                  <a:srgbClr val="0B0B0B"/>
-                </a:solidFill>
-                <a:latin typeface="Calibri"/>
-              </a:rPr>
-              <a:t>●   Verified directly in the receiver implementation: the LiFi data-frame path checks only CRC and byte-exact nonce identity — no timestamp, no round-trip bound</a:t>
-            </a:r>
-          </a:p>
-          <a:p>
-            <a:pPr>
-              <a:spcAft>
-                <a:spcPts val="1100"/>
-              </a:spcAft>
-            </a:pPr>
-            <a:r>
-              <a:rPr sz="1700">
-                <a:solidFill>
-                  <a:srgbClr val="0B0B0B"/>
-                </a:solidFill>
-                <a:latin typeface="Calibri"/>
-              </a:rPr>
-              <a:t>●   What closing this gap requires: a Brands–Chaum-style distance-bounding challenge-response, binding authorization to measured round-trip time</a:t>
-            </a:r>
-          </a:p>
-        </p:txBody>
-      </p:sp>
-      <p:pic>
-        <p:nvPicPr>
-          <p:cNvPr id="4" name="Picture 3" descr="A white background with text&#10;&#10;AI-generated content may be incorrect.">
-            <a:extLst>
-              <a:ext uri="{FF2B5EF4-FFF2-40B4-BE49-F238E27FC236}">
-                <a16:creationId xmlns:a16="http://schemas.microsoft.com/office/drawing/2014/main" id="{0BB6CE34-40C2-0B05-8971-B7281C4F44AB}"/>
-              </a:ext>
-            </a:extLst>
-          </p:cNvPr>
-          <p:cNvPicPr>
-            <a:picLocks noChangeAspect="1"/>
-          </p:cNvPicPr>
-          <p:nvPr/>
-        </p:nvPicPr>
-        <p:blipFill>
-          <a:blip r:embed="rId3"/>
-          <a:stretch>
-            <a:fillRect/>
-          </a:stretch>
-        </p:blipFill>
-        <p:spPr>
-          <a:xfrm>
-            <a:off x="9545121" y="-4718"/>
-            <a:ext cx="2646879" cy="1477328"/>
-          </a:xfrm>
-          <a:prstGeom prst="rect">
-            <a:avLst/>
-          </a:prstGeom>
-        </p:spPr>
-      </p:pic>
-      <p:sp>
-        <p:nvSpPr>
-          <p:cNvPr id="5" name="Rectangle 4">
-            <a:extLst>
-              <a:ext uri="{FF2B5EF4-FFF2-40B4-BE49-F238E27FC236}">
-                <a16:creationId xmlns:a16="http://schemas.microsoft.com/office/drawing/2014/main" id="{B3523F97-9585-DF87-5CEF-7FE7F49B935D}"/>
-              </a:ext>
-            </a:extLst>
-          </p:cNvPr>
-          <p:cNvSpPr/>
-          <p:nvPr/>
-        </p:nvSpPr>
-        <p:spPr>
-          <a:xfrm>
-            <a:off x="0" y="0"/>
-            <a:ext cx="9545121" cy="517206"/>
-          </a:xfrm>
-          <a:prstGeom prst="rect">
-            <a:avLst/>
-          </a:prstGeom>
-          <a:solidFill>
-            <a:srgbClr val="ECBE44"/>
-          </a:solidFill>
-          <a:ln>
-            <a:solidFill>
-              <a:schemeClr val="bg1"/>
-            </a:solidFill>
-          </a:ln>
-        </p:spPr>
-        <p:style>
-          <a:lnRef idx="2">
-            <a:schemeClr val="accent1">
-              <a:shade val="15000"/>
-            </a:schemeClr>
-          </a:lnRef>
-          <a:fillRef idx="1">
-            <a:schemeClr val="accent1"/>
-          </a:fillRef>
-          <a:effectRef idx="0">
-            <a:schemeClr val="accent1"/>
-          </a:effectRef>
-          <a:fontRef idx="minor">
-            <a:schemeClr val="lt1"/>
-          </a:fontRef>
-        </p:style>
-        <p:txBody>
-          <a:bodyPr rtlCol="0" anchor="ctr"/>
-          <a:lstStyle/>
-          <a:p>
-            <a:pPr algn="ctr"/>
-            <a:endParaRPr lang="en-US" dirty="0">
-              <a:solidFill>
-                <a:srgbClr val="FF0000"/>
-              </a:solidFill>
-              <a:highlight>
-                <a:srgbClr val="FFFF00"/>
-              </a:highlight>
-            </a:endParaRPr>
-          </a:p>
-        </p:txBody>
-      </p:sp>
-    </p:spTree>
-  </p:cSld>
-  <p:clrMapOvr>
-    <a:masterClrMapping/>
-  </p:clrMapOvr>
-</p:sld>
-</file>
-
-<file path=ppt/slides/slide25.xml><?xml version="1.0" encoding="utf-8"?>
 <p:sld xmlns:a="http://schemas.openxmlformats.org/drawingml/2006/main" xmlns:r="http://schemas.openxmlformats.org/officeDocument/2006/relationships" xmlns:p="http://schemas.openxmlformats.org/presentationml/2006/main">
   <p:cSld>
     <p:bg>
@@ -16368,7 +16046,7 @@
 </p:sld>
 </file>
 
-<file path=ppt/slides/slide26.xml><?xml version="1.0" encoding="utf-8"?>
+<file path=ppt/slides/slide25.xml><?xml version="1.0" encoding="utf-8"?>
 <p:sld xmlns:a="http://schemas.openxmlformats.org/drawingml/2006/main" xmlns:r="http://schemas.openxmlformats.org/officeDocument/2006/relationships" xmlns:p="http://schemas.openxmlformats.org/presentationml/2006/main">
   <p:cSld>
     <p:bg>
@@ -16645,7 +16323,7 @@
 </p:sld>
 </file>
 
-<file path=ppt/slides/slide27.xml><?xml version="1.0" encoding="utf-8"?>
+<file path=ppt/slides/slide26.xml><?xml version="1.0" encoding="utf-8"?>
 <p:sld xmlns:a="http://schemas.openxmlformats.org/drawingml/2006/main" xmlns:r="http://schemas.openxmlformats.org/officeDocument/2006/relationships" xmlns:p="http://schemas.openxmlformats.org/presentationml/2006/main">
   <p:cSld>
     <p:bg>
@@ -17063,7 +16741,7 @@
 </p:sld>
 </file>
 
-<file path=ppt/slides/slide28.xml><?xml version="1.0" encoding="utf-8"?>
+<file path=ppt/slides/slide27.xml><?xml version="1.0" encoding="utf-8"?>
 <p:sld xmlns:a="http://schemas.openxmlformats.org/drawingml/2006/main" xmlns:r="http://schemas.openxmlformats.org/officeDocument/2006/relationships" xmlns:p="http://schemas.openxmlformats.org/presentationml/2006/main">
   <p:cSld>
     <p:bg>
@@ -17340,7 +17018,7 @@
 </p:sld>
 </file>
 
-<file path=ppt/slides/slide29.xml><?xml version="1.0" encoding="utf-8"?>
+<file path=ppt/slides/slide28.xml><?xml version="1.0" encoding="utf-8"?>
 <p:sld xmlns:a="http://schemas.openxmlformats.org/drawingml/2006/main" xmlns:r="http://schemas.openxmlformats.org/officeDocument/2006/relationships" xmlns:p="http://schemas.openxmlformats.org/presentationml/2006/main">
   <p:cSld>
     <p:spTree>
@@ -17695,6 +17373,162 @@
         <p14:creationId xmlns:p14="http://schemas.microsoft.com/office/powerpoint/2010/main" val="636103872"/>
       </p:ext>
     </p:extLst>
+  </p:cSld>
+  <p:clrMapOvr>
+    <a:masterClrMapping/>
+  </p:clrMapOvr>
+</p:sld>
+</file>
+
+<file path=ppt/slides/slide29.xml><?xml version="1.0" encoding="utf-8"?>
+<p:sld xmlns:a="http://schemas.openxmlformats.org/drawingml/2006/main" xmlns:r="http://schemas.openxmlformats.org/officeDocument/2006/relationships" xmlns:p="http://schemas.openxmlformats.org/presentationml/2006/main">
+  <p:cSld>
+    <p:bg>
+      <p:bgPr>
+        <a:solidFill>
+          <a:srgbClr val="FCFCFB"/>
+        </a:solidFill>
+        <a:effectLst/>
+      </p:bgPr>
+    </p:bg>
+    <p:spTree>
+      <p:nvGrpSpPr>
+        <p:cNvPr id="1" name=""/>
+        <p:cNvGrpSpPr/>
+        <p:nvPr/>
+      </p:nvGrpSpPr>
+      <p:grpSpPr>
+        <a:xfrm>
+          <a:off x="0" y="0"/>
+          <a:ext cx="0" cy="0"/>
+          <a:chOff x="0" y="0"/>
+          <a:chExt cx="0" cy="0"/>
+        </a:xfrm>
+      </p:grpSpPr>
+      <p:sp>
+        <p:nvSpPr>
+          <p:cNvPr id="2" name="Rectangle 1"/>
+          <p:cNvSpPr/>
+          <p:nvPr/>
+        </p:nvSpPr>
+        <p:spPr>
+          <a:xfrm>
+            <a:off x="0" y="0"/>
+            <a:ext cx="12191695" cy="6858000"/>
+          </a:xfrm>
+          <a:prstGeom prst="rect">
+            <a:avLst/>
+          </a:prstGeom>
+          <a:solidFill>
+            <a:srgbClr val="0B0B0B"/>
+          </a:solidFill>
+          <a:ln>
+            <a:noFill/>
+          </a:ln>
+        </p:spPr>
+        <p:style>
+          <a:lnRef idx="1">
+            <a:schemeClr val="accent1"/>
+          </a:lnRef>
+          <a:fillRef idx="3">
+            <a:schemeClr val="accent1"/>
+          </a:fillRef>
+          <a:effectRef idx="2">
+            <a:schemeClr val="accent1"/>
+          </a:effectRef>
+          <a:fontRef idx="minor">
+            <a:schemeClr val="lt1"/>
+          </a:fontRef>
+        </p:style>
+        <p:txBody>
+          <a:bodyPr rtlCol="0" anchor="ctr"/>
+          <a:lstStyle/>
+          <a:p>
+            <a:pPr algn="ctr"/>
+            <a:endParaRPr/>
+          </a:p>
+        </p:txBody>
+      </p:sp>
+      <p:sp>
+        <p:nvSpPr>
+          <p:cNvPr id="3" name="TextBox 2"/>
+          <p:cNvSpPr txBox="1"/>
+          <p:nvPr/>
+        </p:nvSpPr>
+        <p:spPr>
+          <a:xfrm>
+            <a:off x="914400" y="2560320"/>
+            <a:ext cx="10332720" cy="1097280"/>
+          </a:xfrm>
+          <a:prstGeom prst="rect">
+            <a:avLst/>
+          </a:prstGeom>
+          <a:noFill/>
+        </p:spPr>
+        <p:txBody>
+          <a:bodyPr wrap="none">
+            <a:spAutoFit/>
+          </a:bodyPr>
+          <a:lstStyle/>
+          <a:p>
+            <a:r>
+              <a:rPr sz="4000" b="1">
+                <a:solidFill>
+                  <a:srgbClr val="FFFFFF"/>
+                </a:solidFill>
+                <a:latin typeface="Calibri"/>
+              </a:rPr>
+              <a:t>Thank you — Questions</a:t>
+            </a:r>
+          </a:p>
+        </p:txBody>
+      </p:sp>
+      <p:sp>
+        <p:nvSpPr>
+          <p:cNvPr id="4" name="TextBox 3"/>
+          <p:cNvSpPr txBox="1"/>
+          <p:nvPr/>
+        </p:nvSpPr>
+        <p:spPr>
+          <a:xfrm>
+            <a:off x="914400" y="3429000"/>
+            <a:ext cx="10332720" cy="1371600"/>
+          </a:xfrm>
+          <a:prstGeom prst="rect">
+            <a:avLst/>
+          </a:prstGeom>
+          <a:noFill/>
+        </p:spPr>
+        <p:txBody>
+          <a:bodyPr wrap="square">
+            <a:spAutoFit/>
+          </a:bodyPr>
+          <a:lstStyle/>
+          <a:p>
+            <a:r>
+              <a:rPr sz="1500">
+                <a:solidFill>
+                  <a:srgbClr val="C3C2B7"/>
+                </a:solidFill>
+                <a:latin typeface="Calibri"/>
+              </a:rPr>
+              <a:t>Jose Felix · KIM Labs, Arizona State University</a:t>
+            </a:r>
+          </a:p>
+          <a:p>
+            <a:r>
+              <a:rPr sz="1300">
+                <a:solidFill>
+                  <a:srgbClr val="898781"/>
+                </a:solidFill>
+                <a:latin typeface="Calibri"/>
+              </a:rPr>
+              <a:t>github.com/asu-kim/lifi-auth</a:t>
+            </a:r>
+          </a:p>
+        </p:txBody>
+      </p:sp>
+    </p:spTree>
   </p:cSld>
   <p:clrMapOvr>
     <a:masterClrMapping/>
@@ -18305,162 +18139,6 @@
         </p:nvSpPr>
         <p:spPr>
           <a:xfrm>
-            <a:off x="914400" y="2560320"/>
-            <a:ext cx="10332720" cy="1097280"/>
-          </a:xfrm>
-          <a:prstGeom prst="rect">
-            <a:avLst/>
-          </a:prstGeom>
-          <a:noFill/>
-        </p:spPr>
-        <p:txBody>
-          <a:bodyPr wrap="none">
-            <a:spAutoFit/>
-          </a:bodyPr>
-          <a:lstStyle/>
-          <a:p>
-            <a:r>
-              <a:rPr sz="4000" b="1">
-                <a:solidFill>
-                  <a:srgbClr val="FFFFFF"/>
-                </a:solidFill>
-                <a:latin typeface="Calibri"/>
-              </a:rPr>
-              <a:t>Thank you — Questions</a:t>
-            </a:r>
-          </a:p>
-        </p:txBody>
-      </p:sp>
-      <p:sp>
-        <p:nvSpPr>
-          <p:cNvPr id="4" name="TextBox 3"/>
-          <p:cNvSpPr txBox="1"/>
-          <p:nvPr/>
-        </p:nvSpPr>
-        <p:spPr>
-          <a:xfrm>
-            <a:off x="914400" y="3429000"/>
-            <a:ext cx="10332720" cy="1371600"/>
-          </a:xfrm>
-          <a:prstGeom prst="rect">
-            <a:avLst/>
-          </a:prstGeom>
-          <a:noFill/>
-        </p:spPr>
-        <p:txBody>
-          <a:bodyPr wrap="square">
-            <a:spAutoFit/>
-          </a:bodyPr>
-          <a:lstStyle/>
-          <a:p>
-            <a:r>
-              <a:rPr sz="1500">
-                <a:solidFill>
-                  <a:srgbClr val="C3C2B7"/>
-                </a:solidFill>
-                <a:latin typeface="Calibri"/>
-              </a:rPr>
-              <a:t>Jose Felix · KIM Labs, Arizona State University</a:t>
-            </a:r>
-          </a:p>
-          <a:p>
-            <a:r>
-              <a:rPr sz="1300">
-                <a:solidFill>
-                  <a:srgbClr val="898781"/>
-                </a:solidFill>
-                <a:latin typeface="Calibri"/>
-              </a:rPr>
-              <a:t>github.com/asu-kim/lifi-auth</a:t>
-            </a:r>
-          </a:p>
-        </p:txBody>
-      </p:sp>
-    </p:spTree>
-  </p:cSld>
-  <p:clrMapOvr>
-    <a:masterClrMapping/>
-  </p:clrMapOvr>
-</p:sld>
-</file>
-
-<file path=ppt/slides/slide31.xml><?xml version="1.0" encoding="utf-8"?>
-<p:sld xmlns:a="http://schemas.openxmlformats.org/drawingml/2006/main" xmlns:r="http://schemas.openxmlformats.org/officeDocument/2006/relationships" xmlns:p="http://schemas.openxmlformats.org/presentationml/2006/main">
-  <p:cSld>
-    <p:bg>
-      <p:bgPr>
-        <a:solidFill>
-          <a:srgbClr val="FCFCFB"/>
-        </a:solidFill>
-        <a:effectLst/>
-      </p:bgPr>
-    </p:bg>
-    <p:spTree>
-      <p:nvGrpSpPr>
-        <p:cNvPr id="1" name=""/>
-        <p:cNvGrpSpPr/>
-        <p:nvPr/>
-      </p:nvGrpSpPr>
-      <p:grpSpPr>
-        <a:xfrm>
-          <a:off x="0" y="0"/>
-          <a:ext cx="0" cy="0"/>
-          <a:chOff x="0" y="0"/>
-          <a:chExt cx="0" cy="0"/>
-        </a:xfrm>
-      </p:grpSpPr>
-      <p:sp>
-        <p:nvSpPr>
-          <p:cNvPr id="2" name="Rectangle 1"/>
-          <p:cNvSpPr/>
-          <p:nvPr/>
-        </p:nvSpPr>
-        <p:spPr>
-          <a:xfrm>
-            <a:off x="0" y="0"/>
-            <a:ext cx="12191695" cy="6858000"/>
-          </a:xfrm>
-          <a:prstGeom prst="rect">
-            <a:avLst/>
-          </a:prstGeom>
-          <a:solidFill>
-            <a:srgbClr val="0B0B0B"/>
-          </a:solidFill>
-          <a:ln>
-            <a:noFill/>
-          </a:ln>
-        </p:spPr>
-        <p:style>
-          <a:lnRef idx="1">
-            <a:schemeClr val="accent1"/>
-          </a:lnRef>
-          <a:fillRef idx="3">
-            <a:schemeClr val="accent1"/>
-          </a:fillRef>
-          <a:effectRef idx="2">
-            <a:schemeClr val="accent1"/>
-          </a:effectRef>
-          <a:fontRef idx="minor">
-            <a:schemeClr val="lt1"/>
-          </a:fontRef>
-        </p:style>
-        <p:txBody>
-          <a:bodyPr rtlCol="0" anchor="ctr"/>
-          <a:lstStyle/>
-          <a:p>
-            <a:pPr algn="ctr"/>
-            <a:endParaRPr/>
-          </a:p>
-        </p:txBody>
-      </p:sp>
-      <p:sp>
-        <p:nvSpPr>
-          <p:cNvPr id="3" name="TextBox 2"/>
-          <p:cNvSpPr txBox="1"/>
-          <p:nvPr/>
-        </p:nvSpPr>
-        <p:spPr>
-          <a:xfrm>
             <a:off x="914400" y="2743200"/>
             <a:ext cx="10332720" cy="1097280"/>
           </a:xfrm>
@@ -18529,7 +18207,7 @@
 </p:sld>
 </file>
 
-<file path=ppt/slides/slide32.xml><?xml version="1.0" encoding="utf-8"?>
+<file path=ppt/slides/slide31.xml><?xml version="1.0" encoding="utf-8"?>
 <p:sld xmlns:a="http://schemas.openxmlformats.org/drawingml/2006/main" xmlns:r="http://schemas.openxmlformats.org/officeDocument/2006/relationships" xmlns:p="http://schemas.openxmlformats.org/presentationml/2006/main">
   <p:cSld>
     <p:bg>
@@ -19739,7 +19417,7 @@
 </p:sld>
 </file>
 
-<file path=ppt/slides/slide33.xml><?xml version="1.0" encoding="utf-8"?>
+<file path=ppt/slides/slide32.xml><?xml version="1.0" encoding="utf-8"?>
 <p:sld xmlns:a="http://schemas.openxmlformats.org/drawingml/2006/main" xmlns:r="http://schemas.openxmlformats.org/officeDocument/2006/relationships" xmlns:p="http://schemas.openxmlformats.org/presentationml/2006/main">
   <p:cSld>
     <p:bg>
@@ -20494,7 +20172,7 @@
 </p:sld>
 </file>
 
-<file path=ppt/slides/slide34.xml><?xml version="1.0" encoding="utf-8"?>
+<file path=ppt/slides/slide33.xml><?xml version="1.0" encoding="utf-8"?>
 <p:sld xmlns:a="http://schemas.openxmlformats.org/drawingml/2006/main" xmlns:r="http://schemas.openxmlformats.org/officeDocument/2006/relationships" xmlns:p="http://schemas.openxmlformats.org/presentationml/2006/main">
   <p:cSld>
     <p:bg>
@@ -20664,7 +20342,7 @@
 </p:sld>
 </file>
 
-<file path=ppt/slides/slide35.xml><?xml version="1.0" encoding="utf-8"?>
+<file path=ppt/slides/slide34.xml><?xml version="1.0" encoding="utf-8"?>
 <p:sld xmlns:a="http://schemas.openxmlformats.org/drawingml/2006/main" xmlns:r="http://schemas.openxmlformats.org/officeDocument/2006/relationships" xmlns:p="http://schemas.openxmlformats.org/presentationml/2006/main">
   <p:cSld>
     <p:bg>
@@ -21435,7 +21113,7 @@
 </p:sld>
 </file>
 
-<file path=ppt/slides/slide36.xml><?xml version="1.0" encoding="utf-8"?>
+<file path=ppt/slides/slide35.xml><?xml version="1.0" encoding="utf-8"?>
 <p:sld xmlns:a="http://schemas.openxmlformats.org/drawingml/2006/main" xmlns:r="http://schemas.openxmlformats.org/officeDocument/2006/relationships" xmlns:p="http://schemas.openxmlformats.org/presentationml/2006/main">
   <p:cSld>
     <p:bg>
@@ -21639,513 +21317,7 @@
 </p:sld>
 </file>
 
-<file path=ppt/slides/slide37.xml><?xml version="1.0" encoding="utf-8"?>
-<p:sld xmlns:a="http://schemas.openxmlformats.org/drawingml/2006/main" xmlns:r="http://schemas.openxmlformats.org/officeDocument/2006/relationships" xmlns:p="http://schemas.openxmlformats.org/presentationml/2006/main">
-  <p:cSld>
-    <p:bg>
-      <p:bgPr>
-        <a:solidFill>
-          <a:srgbClr val="FCFCFB"/>
-        </a:solidFill>
-        <a:effectLst/>
-      </p:bgPr>
-    </p:bg>
-    <p:spTree>
-      <p:nvGrpSpPr>
-        <p:cNvPr id="1" name=""/>
-        <p:cNvGrpSpPr/>
-        <p:nvPr/>
-      </p:nvGrpSpPr>
-      <p:grpSpPr>
-        <a:xfrm>
-          <a:off x="0" y="0"/>
-          <a:ext cx="0" cy="0"/>
-          <a:chOff x="0" y="0"/>
-          <a:chExt cx="0" cy="0"/>
-        </a:xfrm>
-      </p:grpSpPr>
-      <p:sp>
-        <p:nvSpPr>
-          <p:cNvPr id="2" name="TextBox 1"/>
-          <p:cNvSpPr txBox="1"/>
-          <p:nvPr/>
-        </p:nvSpPr>
-        <p:spPr>
-          <a:xfrm>
-            <a:off x="502920" y="320040"/>
-            <a:ext cx="11155680" cy="822960"/>
-          </a:xfrm>
-          <a:prstGeom prst="rect">
-            <a:avLst/>
-          </a:prstGeom>
-          <a:noFill/>
-        </p:spPr>
-        <p:txBody>
-          <a:bodyPr wrap="square">
-            <a:spAutoFit/>
-          </a:bodyPr>
-          <a:lstStyle/>
-          <a:p>
-            <a:r>
-              <a:rPr sz="2900" b="1">
-                <a:solidFill>
-                  <a:srgbClr val="0B0B0B"/>
-                </a:solidFill>
-                <a:latin typeface="Calibri"/>
-              </a:rPr>
-              <a:t>Backup — Three Receiver Variants, Three Auth Interaction Models</a:t>
-            </a:r>
-          </a:p>
-        </p:txBody>
-      </p:sp>
-      <p:graphicFrame>
-        <p:nvGraphicFramePr>
-          <p:cNvPr id="3" name="Table 2"/>
-          <p:cNvGraphicFramePr>
-            <a:graphicFrameLocks noGrp="1"/>
-          </p:cNvGraphicFramePr>
-          <p:nvPr/>
-        </p:nvGraphicFramePr>
-        <p:xfrm>
-          <a:off x="685800" y="1691640"/>
-          <a:ext cx="11430000" cy="2011680"/>
-        </p:xfrm>
-        <a:graphic>
-          <a:graphicData uri="http://schemas.openxmlformats.org/drawingml/2006/table">
-            <a:tbl>
-              <a:tblPr firstRow="1" bandRow="1">
-                <a:tableStyleId>{5C22544A-7EE6-4342-B048-85BDC9FD1C3A}</a:tableStyleId>
-              </a:tblPr>
-              <a:tblGrid>
-                <a:gridCol w="2377440">
-                  <a:extLst>
-                    <a:ext uri="{9D8B030D-6E8A-4147-A177-3AD203B41FA5}">
-                      <a16:colId xmlns:a16="http://schemas.microsoft.com/office/drawing/2014/main" val="20000"/>
-                    </a:ext>
-                  </a:extLst>
-                </a:gridCol>
-                <a:gridCol w="2011680">
-                  <a:extLst>
-                    <a:ext uri="{9D8B030D-6E8A-4147-A177-3AD203B41FA5}">
-                      <a16:colId xmlns:a16="http://schemas.microsoft.com/office/drawing/2014/main" val="20001"/>
-                    </a:ext>
-                  </a:extLst>
-                </a:gridCol>
-                <a:gridCol w="7040880">
-                  <a:extLst>
-                    <a:ext uri="{9D8B030D-6E8A-4147-A177-3AD203B41FA5}">
-                      <a16:colId xmlns:a16="http://schemas.microsoft.com/office/drawing/2014/main" val="20002"/>
-                    </a:ext>
-                  </a:extLst>
-                </a:gridCol>
-              </a:tblGrid>
-              <a:tr h="502920">
-                <a:tc>
-                  <a:txBody>
-                    <a:bodyPr/>
-                    <a:lstStyle/>
-                    <a:p>
-                      <a:pPr algn="l"/>
-                      <a:r>
-                        <a:rPr sz="1350" b="1">
-                          <a:solidFill>
-                            <a:srgbClr val="FFFFFF"/>
-                          </a:solidFill>
-                          <a:latin typeface="Calibri"/>
-                        </a:rPr>
-                        <a:t>Binary</a:t>
-                      </a:r>
-                    </a:p>
-                  </a:txBody>
-                  <a:tcPr anchor="ctr">
-                    <a:solidFill>
-                      <a:srgbClr val="0B0B0B"/>
-                    </a:solidFill>
-                  </a:tcPr>
-                </a:tc>
-                <a:tc>
-                  <a:txBody>
-                    <a:bodyPr/>
-                    <a:lstStyle/>
-                    <a:p>
-                      <a:pPr algn="ctr"/>
-                      <a:r>
-                        <a:rPr sz="1350" b="1">
-                          <a:solidFill>
-                            <a:srgbClr val="FFFFFF"/>
-                          </a:solidFill>
-                          <a:latin typeface="Calibri"/>
-                        </a:rPr>
-                        <a:t>Role</a:t>
-                      </a:r>
-                    </a:p>
-                  </a:txBody>
-                  <a:tcPr anchor="ctr">
-                    <a:solidFill>
-                      <a:srgbClr val="0B0B0B"/>
-                    </a:solidFill>
-                  </a:tcPr>
-                </a:tc>
-                <a:tc>
-                  <a:txBody>
-                    <a:bodyPr/>
-                    <a:lstStyle/>
-                    <a:p>
-                      <a:pPr algn="ctr"/>
-                      <a:r>
-                        <a:rPr sz="1350" b="1">
-                          <a:solidFill>
-                            <a:srgbClr val="FFFFFF"/>
-                          </a:solidFill>
-                          <a:latin typeface="Calibri"/>
-                        </a:rPr>
-                        <a:t>Auth interaction</a:t>
-                      </a:r>
-                    </a:p>
-                  </a:txBody>
-                  <a:tcPr anchor="ctr">
-                    <a:solidFill>
-                      <a:srgbClr val="0B0B0B"/>
-                    </a:solidFill>
-                  </a:tcPr>
-                </a:tc>
-                <a:extLst>
-                  <a:ext uri="{0D108BD9-81ED-4DB2-BD59-A6C34878D82A}">
-                    <a16:rowId xmlns:a16="http://schemas.microsoft.com/office/drawing/2014/main" val="10000"/>
-                  </a:ext>
-                </a:extLst>
-              </a:tr>
-              <a:tr h="502920">
-                <a:tc>
-                  <a:txBody>
-                    <a:bodyPr/>
-                    <a:lstStyle/>
-                    <a:p>
-                      <a:pPr algn="l"/>
-                      <a:r>
-                        <a:rPr sz="1250" b="0">
-                          <a:solidFill>
-                            <a:srgbClr val="0B0B0B"/>
-                          </a:solidFill>
-                          <a:latin typeface="Calibri"/>
-                        </a:rPr>
-                        <a:t>keys_receiver</a:t>
-                      </a:r>
-                    </a:p>
-                  </a:txBody>
-                  <a:tcPr anchor="ctr">
-                    <a:solidFill>
-                      <a:srgbClr val="FFFFFF"/>
-                    </a:solidFill>
-                  </a:tcPr>
-                </a:tc>
-                <a:tc>
-                  <a:txBody>
-                    <a:bodyPr/>
-                    <a:lstStyle/>
-                    <a:p>
-                      <a:pPr algn="ctr"/>
-                      <a:r>
-                        <a:rPr sz="1250" b="0">
-                          <a:solidFill>
-                            <a:srgbClr val="0B0B0B"/>
-                          </a:solidFill>
-                          <a:latin typeface="Calibri"/>
-                        </a:rPr>
-                        <a:t>“The Manager”</a:t>
-                      </a:r>
-                    </a:p>
-                  </a:txBody>
-                  <a:tcPr anchor="ctr">
-                    <a:solidFill>
-                      <a:srgbClr val="FFFFFF"/>
-                    </a:solidFill>
-                  </a:tcPr>
-                </a:tc>
-                <a:tc>
-                  <a:txBody>
-                    <a:bodyPr/>
-                    <a:lstStyle/>
-                    <a:p>
-                      <a:pPr algn="ctr"/>
-                      <a:r>
-                        <a:rPr sz="1250" b="0">
-                          <a:solidFill>
-                            <a:srgbClr val="0B0B0B"/>
-                          </a:solidFill>
-                          <a:latin typeface="Calibri"/>
-                        </a:rPr>
-                        <a:t>Fetches a session key from Auth at startup, pushes it to the sender</a:t>
-                      </a:r>
-                    </a:p>
-                  </a:txBody>
-                  <a:tcPr anchor="ctr">
-                    <a:solidFill>
-                      <a:srgbClr val="FFFFFF"/>
-                    </a:solidFill>
-                  </a:tcPr>
-                </a:tc>
-                <a:extLst>
-                  <a:ext uri="{0D108BD9-81ED-4DB2-BD59-A6C34878D82A}">
-                    <a16:rowId xmlns:a16="http://schemas.microsoft.com/office/drawing/2014/main" val="10001"/>
-                  </a:ext>
-                </a:extLst>
-              </a:tr>
-              <a:tr h="502920">
-                <a:tc>
-                  <a:txBody>
-                    <a:bodyPr/>
-                    <a:lstStyle/>
-                    <a:p>
-                      <a:pPr algn="l"/>
-                      <a:r>
-                        <a:rPr sz="1250" b="0">
-                          <a:solidFill>
-                            <a:srgbClr val="0B0B0B"/>
-                          </a:solidFill>
-                          <a:latin typeface="Calibri"/>
-                        </a:rPr>
-                        <a:t>flash_receiver</a:t>
-                      </a:r>
-                    </a:p>
-                  </a:txBody>
-                  <a:tcPr anchor="ctr">
-                    <a:solidFill>
-                      <a:srgbClr val="F0EFEC"/>
-                    </a:solidFill>
-                  </a:tcPr>
-                </a:tc>
-                <a:tc>
-                  <a:txBody>
-                    <a:bodyPr/>
-                    <a:lstStyle/>
-                    <a:p>
-                      <a:pPr algn="ctr"/>
-                      <a:r>
-                        <a:rPr sz="1250" b="0">
-                          <a:solidFill>
-                            <a:srgbClr val="0B0B0B"/>
-                          </a:solidFill>
-                          <a:latin typeface="Calibri"/>
-                        </a:rPr>
-                        <a:t>Combined session app</a:t>
-                      </a:r>
-                    </a:p>
-                  </a:txBody>
-                  <a:tcPr anchor="ctr">
-                    <a:solidFill>
-                      <a:srgbClr val="F0EFEC"/>
-                    </a:solidFill>
-                  </a:tcPr>
-                </a:tc>
-                <a:tc>
-                  <a:txBody>
-                    <a:bodyPr/>
-                    <a:lstStyle/>
-                    <a:p>
-                      <a:pPr algn="ctr"/>
-                      <a:r>
-                        <a:rPr sz="1250" b="0">
-                          <a:solidFill>
-                            <a:srgbClr val="0B0B0B"/>
-                          </a:solidFill>
-                          <a:latin typeface="Calibri"/>
-                        </a:rPr>
-                        <a:t>Chat + file transfer + HMAC verification + key management, combined</a:t>
-                      </a:r>
-                    </a:p>
-                  </a:txBody>
-                  <a:tcPr anchor="ctr">
-                    <a:solidFill>
-                      <a:srgbClr val="F0EFEC"/>
-                    </a:solidFill>
-                  </a:tcPr>
-                </a:tc>
-                <a:extLst>
-                  <a:ext uri="{0D108BD9-81ED-4DB2-BD59-A6C34878D82A}">
-                    <a16:rowId xmlns:a16="http://schemas.microsoft.com/office/drawing/2014/main" val="10002"/>
-                  </a:ext>
-                </a:extLst>
-              </a:tr>
-              <a:tr h="502920">
-                <a:tc>
-                  <a:txBody>
-                    <a:bodyPr/>
-                    <a:lstStyle/>
-                    <a:p>
-                      <a:pPr algn="l"/>
-                      <a:r>
-                        <a:rPr sz="1250" b="0">
-                          <a:solidFill>
-                            <a:srgbClr val="0B0B0B"/>
-                          </a:solidFill>
-                          <a:latin typeface="Calibri"/>
-                        </a:rPr>
-                        <a:t>ask_receiver</a:t>
-                      </a:r>
-                    </a:p>
-                  </a:txBody>
-                  <a:tcPr anchor="ctr">
-                    <a:solidFill>
-                      <a:srgbClr val="FFFFFF"/>
-                    </a:solidFill>
-                  </a:tcPr>
-                </a:tc>
-                <a:tc>
-                  <a:txBody>
-                    <a:bodyPr/>
-                    <a:lstStyle/>
-                    <a:p>
-                      <a:pPr algn="ctr"/>
-                      <a:r>
-                        <a:rPr sz="1250" b="0">
-                          <a:solidFill>
-                            <a:srgbClr val="0B0B0B"/>
-                          </a:solidFill>
-                          <a:latin typeface="Calibri"/>
-                        </a:rPr>
-                        <a:t>“The Detective”</a:t>
-                      </a:r>
-                    </a:p>
-                  </a:txBody>
-                  <a:tcPr anchor="ctr">
-                    <a:solidFill>
-                      <a:srgbClr val="FFFFFF"/>
-                    </a:solidFill>
-                  </a:tcPr>
-                </a:tc>
-                <a:tc>
-                  <a:txBody>
-                    <a:bodyPr/>
-                    <a:lstStyle/>
-                    <a:p>
-                      <a:pPr algn="ctr"/>
-                      <a:r>
-                        <a:rPr sz="1250" b="0">
-                          <a:solidFill>
-                            <a:srgbClr val="0B0B0B"/>
-                          </a:solidFill>
-                          <a:latin typeface="Calibri"/>
-                        </a:rPr>
-                        <a:t>No keys at start — listens for an optical key-ID broadcast, then queries Auth</a:t>
-                      </a:r>
-                    </a:p>
-                  </a:txBody>
-                  <a:tcPr anchor="ctr">
-                    <a:solidFill>
-                      <a:srgbClr val="FFFFFF"/>
-                    </a:solidFill>
-                  </a:tcPr>
-                </a:tc>
-                <a:extLst>
-                  <a:ext uri="{0D108BD9-81ED-4DB2-BD59-A6C34878D82A}">
-                    <a16:rowId xmlns:a16="http://schemas.microsoft.com/office/drawing/2014/main" val="10003"/>
-                  </a:ext>
-                </a:extLst>
-              </a:tr>
-            </a:tbl>
-          </a:graphicData>
-        </a:graphic>
-      </p:graphicFrame>
-      <p:sp>
-        <p:nvSpPr>
-          <p:cNvPr id="4" name="TextBox 3"/>
-          <p:cNvSpPr txBox="1"/>
-          <p:nvPr/>
-        </p:nvSpPr>
-        <p:spPr>
-          <a:xfrm>
-            <a:off x="502920" y="3931920"/>
-            <a:ext cx="11155680" cy="548640"/>
-          </a:xfrm>
-          <a:prstGeom prst="rect">
-            <a:avLst/>
-          </a:prstGeom>
-          <a:noFill/>
-        </p:spPr>
-        <p:txBody>
-          <a:bodyPr wrap="square">
-            <a:spAutoFit/>
-          </a:bodyPr>
-          <a:lstStyle/>
-          <a:p>
-            <a:pPr algn="ctr"/>
-            <a:r>
-              <a:rPr sz="1250" b="1" i="0">
-                <a:solidFill>
-                  <a:srgbClr val="898781"/>
-                </a:solidFill>
-                <a:latin typeface="Calibri"/>
-              </a:rPr>
-              <a:t>ask_receiver implements the roaming/discovery model shown on the Auth-runtime slide — it is the concrete code behind that diagram, not a conceptual simplification.</a:t>
-            </a:r>
-          </a:p>
-        </p:txBody>
-      </p:sp>
-      <p:sp>
-        <p:nvSpPr>
-          <p:cNvPr id="5" name="TextBox 4"/>
-          <p:cNvSpPr txBox="1"/>
-          <p:nvPr/>
-        </p:nvSpPr>
-        <p:spPr>
-          <a:xfrm>
-            <a:off x="685800" y="4617720"/>
-            <a:ext cx="10789920" cy="1828800"/>
-          </a:xfrm>
-          <a:prstGeom prst="rect">
-            <a:avLst/>
-          </a:prstGeom>
-          <a:noFill/>
-        </p:spPr>
-        <p:txBody>
-          <a:bodyPr wrap="square">
-            <a:spAutoFit/>
-          </a:bodyPr>
-          <a:lstStyle/>
-          <a:p>
-            <a:pPr>
-              <a:spcAft>
-                <a:spcPts val="1100"/>
-              </a:spcAft>
-            </a:pPr>
-            <a:r>
-              <a:rPr sz="1350">
-                <a:solidFill>
-                  <a:srgbClr val="0B0B0B"/>
-                </a:solidFill>
-                <a:latin typeface="Calibri"/>
-              </a:rPr>
-              <a:t>●   Message types relevant to Auth interaction: MSG_TYPE_KEY_ID_ONLY (discovery), MSG_TYPE_CHALLENGE / RESPONSE (runtime HMAC), MSG_TYPE_KEY (provisioning push)</a:t>
-            </a:r>
-          </a:p>
-          <a:p>
-            <a:pPr>
-              <a:spcAft>
-                <a:spcPts val="1100"/>
-              </a:spcAft>
-            </a:pPr>
-            <a:r>
-              <a:rPr sz="1350">
-                <a:solidFill>
-                  <a:srgbClr val="0B0B0B"/>
-                </a:solidFill>
-                <a:latin typeface="Calibri"/>
-              </a:rPr>
-              <a:t>●   All three variants share the same SST C API calls underneath: init_SST(), get_session_key(), get_session_key_by_ID()</a:t>
-            </a:r>
-          </a:p>
-        </p:txBody>
-      </p:sp>
-    </p:spTree>
-  </p:cSld>
-  <p:clrMapOvr>
-    <a:masterClrMapping/>
-  </p:clrMapOvr>
-</p:sld>
-</file>
-
-<file path=ppt/slides/slide38.xml><?xml version="1.0" encoding="utf-8"?>
+<file path=ppt/slides/slide36.xml><?xml version="1.0" encoding="utf-8"?>
 <p:sld xmlns:a="http://schemas.openxmlformats.org/drawingml/2006/main" xmlns:r="http://schemas.openxmlformats.org/officeDocument/2006/relationships" xmlns:p="http://schemas.openxmlformats.org/presentationml/2006/main">
   <p:cSld>
     <p:bg>

</xml_diff>

<commit_message>
Sync the Security Validation recap table to today's confirmed numbers
Slide 24's scorecard table still showed the pre-confirmation G1
number (15.11s +/- 0.06s intrinsic) and didn't mention the n=25
replay-trial results — missed in the earlier per-slide patches since
this table wasn't caught by the Pi4/dashboard keyword scan. Also
fixed the notes' "previous four slides" reference, which no longer
pointed at the right slides after the deck's G3/formal-model section
was inserted between the evidence slides and this recap.
</commit_message>
<xml_diff>
--- a/thesis_defense/lifi_thesis_defense.pptx
+++ b/thesis_defense/lifi_thesis_defense.pptx
@@ -1481,7 +1481,7 @@
           <a:lstStyle/>
           <a:p>
             <a:r>
-              <a:t>This closes the loop back to the Security Goals G1-G4 scorecard slide, now with evidence in the last column instead of just mechanism. Read it goal by goal, evidence-first: this is the moment to sound confident, because everything in the 'evidence' column is a number you already showed them on the previous four slides — you're not introducing anything new here, just tying it together.</a:t>
+              <a:t>This closes the loop back to the Security Goals G1-G4 scorecard slide, now with evidence in the last column instead of just mechanism. Read it goal by goal, evidence-first: this is the moment to sound confident, because everything in the 'evidence' column is a number you already showed them on the Methodology, G4, Δ-sensitivity, and G2 slides earlier in this section — you're not introducing anything new here, just tying it together.</a:t>
             </a:r>
           </a:p>
         </p:txBody>
@@ -15622,15 +15622,8 @@
                     <a:bodyPr/>
                     <a:lstStyle/>
                     <a:p>
-                      <a:pPr algn="ctr"/>
                       <a:r>
-                        <a:rPr sz="1250" b="0">
-                          <a:solidFill>
-                            <a:srgbClr val="0B0B0B"/>
-                          </a:solidFill>
-                          <a:latin typeface="Calibri"/>
-                        </a:rPr>
-                        <a:t>15.11s ± 0.06s intrinsic ≈ Δ + 0.11s</a:t>
+                        <a:t>15.001s ± 0.000s on-device (n=25), confirms Δ + fixed overhead</a:t>
                       </a:r>
                     </a:p>
                   </a:txBody>
@@ -15721,15 +15714,8 @@
                     <a:bodyPr/>
                     <a:lstStyle/>
                     <a:p>
-                      <a:pPr algn="ctr"/>
                       <a:r>
-                        <a:rPr sz="1250" b="0">
-                          <a:solidFill>
-                            <a:srgbClr val="0B0B0B"/>
-                          </a:solidFill>
-                          <a:latin typeface="Calibri"/>
-                        </a:rPr>
-                        <a:t>Immediate rejection confirmed; window-bounded (documented)</a:t>
+                        <a:t>25/25 immediate rejection; window-bound limitation reproduced 25/25</a:t>
                       </a:r>
                     </a:p>
                   </a:txBody>

</xml_diff>